<commit_message>
PnP: word-fit, sheet labels, split single-sided votes; add ochkarikov.
</commit_message>
<xml_diff>
--- a/output/svet-moy-zerkalce-letters.pptx
+++ b/output/svet-moy-zerkalce-letters.pptx
@@ -3103,8 +3103,8 @@
         </p:nvSpPr>
         <p:spPr>
           <a:xfrm>
-            <a:off x="444506" y="184762"/>
-            <a:ext cx="2223662" cy="1720412"/>
+            <a:off x="514302" y="400762"/>
+            <a:ext cx="2177131" cy="1684412"/>
           </a:xfrm>
           <a:prstGeom prst="rect">
             <a:avLst/>
@@ -3130,7 +3130,7 @@
           </a:fontRef>
         </p:style>
         <p:txBody>
-          <a:bodyPr rtlCol="0" anchor="ctr" wrap="none" lIns="58517" rIns="58517" tIns="39011" bIns="39011"/>
+          <a:bodyPr rtlCol="0" anchor="ctr" wrap="none" lIns="57292" rIns="57292" tIns="38195" bIns="38195"/>
           <a:lstStyle/>
           <a:p>
             <a:pPr algn="ctr">
@@ -3161,8 +3161,8 @@
         </p:nvSpPr>
         <p:spPr>
           <a:xfrm>
-            <a:off x="2668168" y="184762"/>
-            <a:ext cx="2223662" cy="1720412"/>
+            <a:off x="2691434" y="400762"/>
+            <a:ext cx="2177131" cy="1684412"/>
           </a:xfrm>
           <a:prstGeom prst="rect">
             <a:avLst/>
@@ -3188,7 +3188,7 @@
           </a:fontRef>
         </p:style>
         <p:txBody>
-          <a:bodyPr rtlCol="0" anchor="ctr" wrap="none" lIns="58517" rIns="58517" tIns="39011" bIns="39011"/>
+          <a:bodyPr rtlCol="0" anchor="ctr" wrap="none" lIns="57292" rIns="57292" tIns="38195" bIns="38195"/>
           <a:lstStyle/>
           <a:p>
             <a:pPr algn="ctr">
@@ -3219,8 +3219,8 @@
         </p:nvSpPr>
         <p:spPr>
           <a:xfrm>
-            <a:off x="4891831" y="184762"/>
-            <a:ext cx="2223662" cy="1720412"/>
+            <a:off x="4868565" y="400762"/>
+            <a:ext cx="2177131" cy="1684412"/>
           </a:xfrm>
           <a:prstGeom prst="rect">
             <a:avLst/>
@@ -3246,7 +3246,7 @@
           </a:fontRef>
         </p:style>
         <p:txBody>
-          <a:bodyPr rtlCol="0" anchor="ctr" wrap="none" lIns="58517" rIns="58517" tIns="39011" bIns="39011"/>
+          <a:bodyPr rtlCol="0" anchor="ctr" wrap="none" lIns="57292" rIns="57292" tIns="38195" bIns="38195"/>
           <a:lstStyle/>
           <a:p>
             <a:pPr algn="ctr">
@@ -3277,8 +3277,8 @@
         </p:nvSpPr>
         <p:spPr>
           <a:xfrm>
-            <a:off x="444506" y="1905175"/>
-            <a:ext cx="2223662" cy="1720412"/>
+            <a:off x="514302" y="2085175"/>
+            <a:ext cx="2177131" cy="1684412"/>
           </a:xfrm>
           <a:prstGeom prst="rect">
             <a:avLst/>
@@ -3304,7 +3304,7 @@
           </a:fontRef>
         </p:style>
         <p:txBody>
-          <a:bodyPr rtlCol="0" anchor="ctr" wrap="none" lIns="58517" rIns="58517" tIns="39011" bIns="39011"/>
+          <a:bodyPr rtlCol="0" anchor="ctr" wrap="none" lIns="57292" rIns="57292" tIns="38195" bIns="38195"/>
           <a:lstStyle/>
           <a:p>
             <a:pPr algn="ctr">
@@ -3335,8 +3335,8 @@
         </p:nvSpPr>
         <p:spPr>
           <a:xfrm>
-            <a:off x="2668168" y="1905175"/>
-            <a:ext cx="2223662" cy="1720412"/>
+            <a:off x="2691434" y="2085175"/>
+            <a:ext cx="2177131" cy="1684412"/>
           </a:xfrm>
           <a:prstGeom prst="rect">
             <a:avLst/>
@@ -3362,7 +3362,7 @@
           </a:fontRef>
         </p:style>
         <p:txBody>
-          <a:bodyPr rtlCol="0" anchor="ctr" wrap="none" lIns="58517" rIns="58517" tIns="39011" bIns="39011"/>
+          <a:bodyPr rtlCol="0" anchor="ctr" wrap="none" lIns="57292" rIns="57292" tIns="38195" bIns="38195"/>
           <a:lstStyle/>
           <a:p>
             <a:pPr algn="ctr">
@@ -3393,8 +3393,8 @@
         </p:nvSpPr>
         <p:spPr>
           <a:xfrm>
-            <a:off x="4891831" y="1905175"/>
-            <a:ext cx="2223662" cy="1720412"/>
+            <a:off x="4868565" y="2085175"/>
+            <a:ext cx="2177131" cy="1684412"/>
           </a:xfrm>
           <a:prstGeom prst="rect">
             <a:avLst/>
@@ -3420,7 +3420,7 @@
           </a:fontRef>
         </p:style>
         <p:txBody>
-          <a:bodyPr rtlCol="0" anchor="ctr" wrap="none" lIns="58517" rIns="58517" tIns="39011" bIns="39011"/>
+          <a:bodyPr rtlCol="0" anchor="ctr" wrap="none" lIns="57292" rIns="57292" tIns="38195" bIns="38195"/>
           <a:lstStyle/>
           <a:p>
             <a:pPr algn="ctr">
@@ -3451,8 +3451,8 @@
         </p:nvSpPr>
         <p:spPr>
           <a:xfrm>
-            <a:off x="444506" y="3625587"/>
-            <a:ext cx="2223662" cy="1720412"/>
+            <a:off x="514302" y="3769587"/>
+            <a:ext cx="2177131" cy="1684412"/>
           </a:xfrm>
           <a:prstGeom prst="rect">
             <a:avLst/>
@@ -3478,7 +3478,7 @@
           </a:fontRef>
         </p:style>
         <p:txBody>
-          <a:bodyPr rtlCol="0" anchor="ctr" wrap="none" lIns="58517" rIns="58517" tIns="39011" bIns="39011"/>
+          <a:bodyPr rtlCol="0" anchor="ctr" wrap="none" lIns="57292" rIns="57292" tIns="38195" bIns="38195"/>
           <a:lstStyle/>
           <a:p>
             <a:pPr algn="ctr">
@@ -3509,8 +3509,8 @@
         </p:nvSpPr>
         <p:spPr>
           <a:xfrm>
-            <a:off x="2668168" y="3625587"/>
-            <a:ext cx="2223662" cy="1720412"/>
+            <a:off x="2691434" y="3769587"/>
+            <a:ext cx="2177131" cy="1684412"/>
           </a:xfrm>
           <a:prstGeom prst="rect">
             <a:avLst/>
@@ -3536,7 +3536,7 @@
           </a:fontRef>
         </p:style>
         <p:txBody>
-          <a:bodyPr rtlCol="0" anchor="ctr" wrap="none" lIns="58517" rIns="58517" tIns="39011" bIns="39011"/>
+          <a:bodyPr rtlCol="0" anchor="ctr" wrap="none" lIns="57292" rIns="57292" tIns="38195" bIns="38195"/>
           <a:lstStyle/>
           <a:p>
             <a:pPr algn="ctr">
@@ -3567,8 +3567,8 @@
         </p:nvSpPr>
         <p:spPr>
           <a:xfrm>
-            <a:off x="4891831" y="3625587"/>
-            <a:ext cx="2223662" cy="1720412"/>
+            <a:off x="4868565" y="3769587"/>
+            <a:ext cx="2177131" cy="1684412"/>
           </a:xfrm>
           <a:prstGeom prst="rect">
             <a:avLst/>
@@ -3594,7 +3594,7 @@
           </a:fontRef>
         </p:style>
         <p:txBody>
-          <a:bodyPr rtlCol="0" anchor="ctr" wrap="none" lIns="58517" rIns="58517" tIns="39011" bIns="39011"/>
+          <a:bodyPr rtlCol="0" anchor="ctr" wrap="none" lIns="57292" rIns="57292" tIns="38195" bIns="38195"/>
           <a:lstStyle/>
           <a:p>
             <a:pPr algn="ctr">
@@ -3625,8 +3625,8 @@
         </p:nvSpPr>
         <p:spPr>
           <a:xfrm>
-            <a:off x="444506" y="5346000"/>
-            <a:ext cx="2223662" cy="1720412"/>
+            <a:off x="514302" y="5454000"/>
+            <a:ext cx="2177131" cy="1684412"/>
           </a:xfrm>
           <a:prstGeom prst="rect">
             <a:avLst/>
@@ -3652,7 +3652,7 @@
           </a:fontRef>
         </p:style>
         <p:txBody>
-          <a:bodyPr rtlCol="0" anchor="ctr" wrap="none" lIns="58517" rIns="58517" tIns="39011" bIns="39011"/>
+          <a:bodyPr rtlCol="0" anchor="ctr" wrap="none" lIns="57292" rIns="57292" tIns="38195" bIns="38195"/>
           <a:lstStyle/>
           <a:p>
             <a:pPr algn="ctr">
@@ -3683,8 +3683,8 @@
         </p:nvSpPr>
         <p:spPr>
           <a:xfrm>
-            <a:off x="2668168" y="5346000"/>
-            <a:ext cx="2223662" cy="1720412"/>
+            <a:off x="2691434" y="5454000"/>
+            <a:ext cx="2177131" cy="1684412"/>
           </a:xfrm>
           <a:prstGeom prst="rect">
             <a:avLst/>
@@ -3710,7 +3710,7 @@
           </a:fontRef>
         </p:style>
         <p:txBody>
-          <a:bodyPr rtlCol="0" anchor="ctr" wrap="none" lIns="58517" rIns="58517" tIns="39011" bIns="39011"/>
+          <a:bodyPr rtlCol="0" anchor="ctr" wrap="none" lIns="57292" rIns="57292" tIns="38195" bIns="38195"/>
           <a:lstStyle/>
           <a:p>
             <a:pPr algn="ctr">
@@ -3741,8 +3741,8 @@
         </p:nvSpPr>
         <p:spPr>
           <a:xfrm>
-            <a:off x="4891831" y="5346000"/>
-            <a:ext cx="2223662" cy="1720412"/>
+            <a:off x="4868565" y="5454000"/>
+            <a:ext cx="2177131" cy="1684412"/>
           </a:xfrm>
           <a:prstGeom prst="rect">
             <a:avLst/>
@@ -3768,7 +3768,7 @@
           </a:fontRef>
         </p:style>
         <p:txBody>
-          <a:bodyPr rtlCol="0" anchor="ctr" wrap="none" lIns="58517" rIns="58517" tIns="39011" bIns="39011"/>
+          <a:bodyPr rtlCol="0" anchor="ctr" wrap="none" lIns="57292" rIns="57292" tIns="38195" bIns="38195"/>
           <a:lstStyle/>
           <a:p>
             <a:pPr algn="ctr">
@@ -3799,8 +3799,8 @@
         </p:nvSpPr>
         <p:spPr>
           <a:xfrm>
-            <a:off x="444506" y="7066412"/>
-            <a:ext cx="2223662" cy="1720412"/>
+            <a:off x="514302" y="7138412"/>
+            <a:ext cx="2177131" cy="1684412"/>
           </a:xfrm>
           <a:prstGeom prst="rect">
             <a:avLst/>
@@ -3826,7 +3826,7 @@
           </a:fontRef>
         </p:style>
         <p:txBody>
-          <a:bodyPr rtlCol="0" anchor="ctr" wrap="none" lIns="58517" rIns="58517" tIns="39011" bIns="39011"/>
+          <a:bodyPr rtlCol="0" anchor="ctr" wrap="none" lIns="57292" rIns="57292" tIns="38195" bIns="38195"/>
           <a:lstStyle/>
           <a:p>
             <a:pPr algn="ctr">
@@ -3857,8 +3857,8 @@
         </p:nvSpPr>
         <p:spPr>
           <a:xfrm>
-            <a:off x="2668168" y="7066412"/>
-            <a:ext cx="2223662" cy="1720412"/>
+            <a:off x="2691434" y="7138412"/>
+            <a:ext cx="2177131" cy="1684412"/>
           </a:xfrm>
           <a:prstGeom prst="rect">
             <a:avLst/>
@@ -3884,7 +3884,7 @@
           </a:fontRef>
         </p:style>
         <p:txBody>
-          <a:bodyPr rtlCol="0" anchor="ctr" wrap="none" lIns="58517" rIns="58517" tIns="39011" bIns="39011"/>
+          <a:bodyPr rtlCol="0" anchor="ctr" wrap="none" lIns="57292" rIns="57292" tIns="38195" bIns="38195"/>
           <a:lstStyle/>
           <a:p>
             <a:pPr algn="ctr">
@@ -3915,8 +3915,8 @@
         </p:nvSpPr>
         <p:spPr>
           <a:xfrm>
-            <a:off x="4891831" y="7066412"/>
-            <a:ext cx="2223662" cy="1720412"/>
+            <a:off x="4868565" y="7138412"/>
+            <a:ext cx="2177131" cy="1684412"/>
           </a:xfrm>
           <a:prstGeom prst="rect">
             <a:avLst/>
@@ -3942,7 +3942,7 @@
           </a:fontRef>
         </p:style>
         <p:txBody>
-          <a:bodyPr rtlCol="0" anchor="ctr" wrap="none" lIns="58517" rIns="58517" tIns="39011" bIns="39011"/>
+          <a:bodyPr rtlCol="0" anchor="ctr" wrap="none" lIns="57292" rIns="57292" tIns="38195" bIns="38195"/>
           <a:lstStyle/>
           <a:p>
             <a:pPr algn="ctr">
@@ -3973,8 +3973,8 @@
         </p:nvSpPr>
         <p:spPr>
           <a:xfrm>
-            <a:off x="444506" y="8786825"/>
-            <a:ext cx="2223662" cy="1720412"/>
+            <a:off x="514302" y="8822825"/>
+            <a:ext cx="2177131" cy="1684412"/>
           </a:xfrm>
           <a:prstGeom prst="rect">
             <a:avLst/>
@@ -4000,7 +4000,7 @@
           </a:fontRef>
         </p:style>
         <p:txBody>
-          <a:bodyPr rtlCol="0" anchor="ctr" wrap="none" lIns="58517" rIns="58517" tIns="39011" bIns="39011"/>
+          <a:bodyPr rtlCol="0" anchor="ctr" wrap="none" lIns="57292" rIns="57292" tIns="38195" bIns="38195"/>
           <a:lstStyle/>
           <a:p>
             <a:pPr algn="ctr">
@@ -4031,8 +4031,8 @@
         </p:nvSpPr>
         <p:spPr>
           <a:xfrm>
-            <a:off x="2668168" y="8786825"/>
-            <a:ext cx="2223662" cy="1720412"/>
+            <a:off x="2691434" y="8822825"/>
+            <a:ext cx="2177131" cy="1684412"/>
           </a:xfrm>
           <a:prstGeom prst="rect">
             <a:avLst/>
@@ -4058,7 +4058,7 @@
           </a:fontRef>
         </p:style>
         <p:txBody>
-          <a:bodyPr rtlCol="0" anchor="ctr" wrap="none" lIns="58517" rIns="58517" tIns="39011" bIns="39011"/>
+          <a:bodyPr rtlCol="0" anchor="ctr" wrap="none" lIns="57292" rIns="57292" tIns="38195" bIns="38195"/>
           <a:lstStyle/>
           <a:p>
             <a:pPr algn="ctr">
@@ -4089,8 +4089,8 @@
         </p:nvSpPr>
         <p:spPr>
           <a:xfrm>
-            <a:off x="4891831" y="8786825"/>
-            <a:ext cx="2223662" cy="1720412"/>
+            <a:off x="4868565" y="8822825"/>
+            <a:ext cx="2177131" cy="1684412"/>
           </a:xfrm>
           <a:prstGeom prst="rect">
             <a:avLst/>
@@ -4116,7 +4116,7 @@
           </a:fontRef>
         </p:style>
         <p:txBody>
-          <a:bodyPr rtlCol="0" anchor="ctr" wrap="none" lIns="58517" rIns="58517" tIns="39011" bIns="39011"/>
+          <a:bodyPr rtlCol="0" anchor="ctr" wrap="none" lIns="57292" rIns="57292" tIns="38195" bIns="38195"/>
           <a:lstStyle/>
           <a:p>
             <a:pPr algn="ctr">
@@ -4147,8 +4147,8 @@
         </p:nvSpPr>
         <p:spPr>
           <a:xfrm>
-            <a:off x="444506" y="180000"/>
-            <a:ext cx="2223662" cy="9525"/>
+            <a:off x="514302" y="396000"/>
+            <a:ext cx="2177131" cy="9525"/>
           </a:xfrm>
           <a:prstGeom prst="rect">
             <a:avLst/>
@@ -4191,8 +4191,8 @@
         </p:nvSpPr>
         <p:spPr>
           <a:xfrm>
-            <a:off x="2668168" y="180000"/>
-            <a:ext cx="2223662" cy="9525"/>
+            <a:off x="2691434" y="396000"/>
+            <a:ext cx="2177131" cy="9525"/>
           </a:xfrm>
           <a:prstGeom prst="rect">
             <a:avLst/>
@@ -4235,8 +4235,8 @@
         </p:nvSpPr>
         <p:spPr>
           <a:xfrm>
-            <a:off x="4891831" y="180000"/>
-            <a:ext cx="2223662" cy="9525"/>
+            <a:off x="4868565" y="396000"/>
+            <a:ext cx="2177131" cy="9525"/>
           </a:xfrm>
           <a:prstGeom prst="rect">
             <a:avLst/>
@@ -4279,8 +4279,8 @@
         </p:nvSpPr>
         <p:spPr>
           <a:xfrm>
-            <a:off x="444506" y="1900412"/>
-            <a:ext cx="2223662" cy="9525"/>
+            <a:off x="514302" y="2080412"/>
+            <a:ext cx="2177131" cy="9525"/>
           </a:xfrm>
           <a:prstGeom prst="rect">
             <a:avLst/>
@@ -4323,8 +4323,8 @@
         </p:nvSpPr>
         <p:spPr>
           <a:xfrm>
-            <a:off x="2668168" y="1900412"/>
-            <a:ext cx="2223662" cy="9525"/>
+            <a:off x="2691434" y="2080412"/>
+            <a:ext cx="2177131" cy="9525"/>
           </a:xfrm>
           <a:prstGeom prst="rect">
             <a:avLst/>
@@ -4367,8 +4367,8 @@
         </p:nvSpPr>
         <p:spPr>
           <a:xfrm>
-            <a:off x="4891831" y="1900412"/>
-            <a:ext cx="2223662" cy="9525"/>
+            <a:off x="4868565" y="2080412"/>
+            <a:ext cx="2177131" cy="9525"/>
           </a:xfrm>
           <a:prstGeom prst="rect">
             <a:avLst/>
@@ -4411,8 +4411,8 @@
         </p:nvSpPr>
         <p:spPr>
           <a:xfrm>
-            <a:off x="444506" y="3620825"/>
-            <a:ext cx="2223662" cy="9525"/>
+            <a:off x="514302" y="3764825"/>
+            <a:ext cx="2177131" cy="9525"/>
           </a:xfrm>
           <a:prstGeom prst="rect">
             <a:avLst/>
@@ -4455,8 +4455,8 @@
         </p:nvSpPr>
         <p:spPr>
           <a:xfrm>
-            <a:off x="2668168" y="3620825"/>
-            <a:ext cx="2223662" cy="9525"/>
+            <a:off x="2691434" y="3764825"/>
+            <a:ext cx="2177131" cy="9525"/>
           </a:xfrm>
           <a:prstGeom prst="rect">
             <a:avLst/>
@@ -4499,8 +4499,8 @@
         </p:nvSpPr>
         <p:spPr>
           <a:xfrm>
-            <a:off x="4891831" y="3620825"/>
-            <a:ext cx="2223662" cy="9525"/>
+            <a:off x="4868565" y="3764825"/>
+            <a:ext cx="2177131" cy="9525"/>
           </a:xfrm>
           <a:prstGeom prst="rect">
             <a:avLst/>
@@ -4543,8 +4543,8 @@
         </p:nvSpPr>
         <p:spPr>
           <a:xfrm>
-            <a:off x="444506" y="5341237"/>
-            <a:ext cx="2223662" cy="9525"/>
+            <a:off x="514302" y="5449237"/>
+            <a:ext cx="2177131" cy="9525"/>
           </a:xfrm>
           <a:prstGeom prst="rect">
             <a:avLst/>
@@ -4587,8 +4587,8 @@
         </p:nvSpPr>
         <p:spPr>
           <a:xfrm>
-            <a:off x="2668168" y="5341237"/>
-            <a:ext cx="2223662" cy="9525"/>
+            <a:off x="2691434" y="5449237"/>
+            <a:ext cx="2177131" cy="9525"/>
           </a:xfrm>
           <a:prstGeom prst="rect">
             <a:avLst/>
@@ -4631,8 +4631,8 @@
         </p:nvSpPr>
         <p:spPr>
           <a:xfrm>
-            <a:off x="4891831" y="5341237"/>
-            <a:ext cx="2223662" cy="9525"/>
+            <a:off x="4868565" y="5449237"/>
+            <a:ext cx="2177131" cy="9525"/>
           </a:xfrm>
           <a:prstGeom prst="rect">
             <a:avLst/>
@@ -4675,8 +4675,8 @@
         </p:nvSpPr>
         <p:spPr>
           <a:xfrm>
-            <a:off x="444506" y="7061650"/>
-            <a:ext cx="2223662" cy="9525"/>
+            <a:off x="514302" y="7133650"/>
+            <a:ext cx="2177131" cy="9525"/>
           </a:xfrm>
           <a:prstGeom prst="rect">
             <a:avLst/>
@@ -4719,8 +4719,8 @@
         </p:nvSpPr>
         <p:spPr>
           <a:xfrm>
-            <a:off x="2668168" y="7061650"/>
-            <a:ext cx="2223662" cy="9525"/>
+            <a:off x="2691434" y="7133650"/>
+            <a:ext cx="2177131" cy="9525"/>
           </a:xfrm>
           <a:prstGeom prst="rect">
             <a:avLst/>
@@ -4763,8 +4763,8 @@
         </p:nvSpPr>
         <p:spPr>
           <a:xfrm>
-            <a:off x="4891831" y="7061650"/>
-            <a:ext cx="2223662" cy="9525"/>
+            <a:off x="4868565" y="7133650"/>
+            <a:ext cx="2177131" cy="9525"/>
           </a:xfrm>
           <a:prstGeom prst="rect">
             <a:avLst/>
@@ -4807,8 +4807,8 @@
         </p:nvSpPr>
         <p:spPr>
           <a:xfrm>
-            <a:off x="444506" y="8782062"/>
-            <a:ext cx="2223662" cy="9525"/>
+            <a:off x="514302" y="8818062"/>
+            <a:ext cx="2177131" cy="9525"/>
           </a:xfrm>
           <a:prstGeom prst="rect">
             <a:avLst/>
@@ -4851,8 +4851,8 @@
         </p:nvSpPr>
         <p:spPr>
           <a:xfrm>
-            <a:off x="2668168" y="8782062"/>
-            <a:ext cx="2223662" cy="9525"/>
+            <a:off x="2691434" y="8818062"/>
+            <a:ext cx="2177131" cy="9525"/>
           </a:xfrm>
           <a:prstGeom prst="rect">
             <a:avLst/>
@@ -4895,8 +4895,8 @@
         </p:nvSpPr>
         <p:spPr>
           <a:xfrm>
-            <a:off x="4891831" y="8782062"/>
-            <a:ext cx="2223662" cy="9525"/>
+            <a:off x="4868565" y="8818062"/>
+            <a:ext cx="2177131" cy="9525"/>
           </a:xfrm>
           <a:prstGeom prst="rect">
             <a:avLst/>
@@ -4939,8 +4939,8 @@
         </p:nvSpPr>
         <p:spPr>
           <a:xfrm>
-            <a:off x="444506" y="10502475"/>
-            <a:ext cx="2223662" cy="9525"/>
+            <a:off x="514302" y="10502475"/>
+            <a:ext cx="2177131" cy="9525"/>
           </a:xfrm>
           <a:prstGeom prst="rect">
             <a:avLst/>
@@ -4983,8 +4983,8 @@
         </p:nvSpPr>
         <p:spPr>
           <a:xfrm>
-            <a:off x="2668168" y="10502475"/>
-            <a:ext cx="2223662" cy="9525"/>
+            <a:off x="2691434" y="10502475"/>
+            <a:ext cx="2177131" cy="9525"/>
           </a:xfrm>
           <a:prstGeom prst="rect">
             <a:avLst/>
@@ -5027,8 +5027,8 @@
         </p:nvSpPr>
         <p:spPr>
           <a:xfrm>
-            <a:off x="4891831" y="10502475"/>
-            <a:ext cx="2223662" cy="9525"/>
+            <a:off x="4868565" y="10502475"/>
+            <a:ext cx="2177131" cy="9525"/>
           </a:xfrm>
           <a:prstGeom prst="rect">
             <a:avLst/>
@@ -5071,8 +5071,8 @@
         </p:nvSpPr>
         <p:spPr>
           <a:xfrm>
-            <a:off x="439743" y="184762"/>
-            <a:ext cx="9525" cy="1720412"/>
+            <a:off x="509539" y="400762"/>
+            <a:ext cx="9525" cy="1684412"/>
           </a:xfrm>
           <a:prstGeom prst="rect">
             <a:avLst/>
@@ -5115,8 +5115,8 @@
         </p:nvSpPr>
         <p:spPr>
           <a:xfrm>
-            <a:off x="439743" y="1905175"/>
-            <a:ext cx="9525" cy="1720412"/>
+            <a:off x="509539" y="2085175"/>
+            <a:ext cx="9525" cy="1684412"/>
           </a:xfrm>
           <a:prstGeom prst="rect">
             <a:avLst/>
@@ -5159,8 +5159,8 @@
         </p:nvSpPr>
         <p:spPr>
           <a:xfrm>
-            <a:off x="439743" y="3625587"/>
-            <a:ext cx="9525" cy="1720412"/>
+            <a:off x="509539" y="3769587"/>
+            <a:ext cx="9525" cy="1684412"/>
           </a:xfrm>
           <a:prstGeom prst="rect">
             <a:avLst/>
@@ -5203,8 +5203,8 @@
         </p:nvSpPr>
         <p:spPr>
           <a:xfrm>
-            <a:off x="439743" y="5346000"/>
-            <a:ext cx="9525" cy="1720412"/>
+            <a:off x="509539" y="5454000"/>
+            <a:ext cx="9525" cy="1684412"/>
           </a:xfrm>
           <a:prstGeom prst="rect">
             <a:avLst/>
@@ -5247,8 +5247,8 @@
         </p:nvSpPr>
         <p:spPr>
           <a:xfrm>
-            <a:off x="439743" y="7066412"/>
-            <a:ext cx="9525" cy="1720412"/>
+            <a:off x="509539" y="7138412"/>
+            <a:ext cx="9525" cy="1684412"/>
           </a:xfrm>
           <a:prstGeom prst="rect">
             <a:avLst/>
@@ -5291,8 +5291,8 @@
         </p:nvSpPr>
         <p:spPr>
           <a:xfrm>
-            <a:off x="439743" y="8786825"/>
-            <a:ext cx="9525" cy="1720412"/>
+            <a:off x="509539" y="8822825"/>
+            <a:ext cx="9525" cy="1684412"/>
           </a:xfrm>
           <a:prstGeom prst="rect">
             <a:avLst/>
@@ -5335,8 +5335,8 @@
         </p:nvSpPr>
         <p:spPr>
           <a:xfrm>
-            <a:off x="2663406" y="184762"/>
-            <a:ext cx="9525" cy="1720412"/>
+            <a:off x="2686671" y="400762"/>
+            <a:ext cx="9525" cy="1684412"/>
           </a:xfrm>
           <a:prstGeom prst="rect">
             <a:avLst/>
@@ -5379,8 +5379,8 @@
         </p:nvSpPr>
         <p:spPr>
           <a:xfrm>
-            <a:off x="2663406" y="1905175"/>
-            <a:ext cx="9525" cy="1720412"/>
+            <a:off x="2686671" y="2085175"/>
+            <a:ext cx="9525" cy="1684412"/>
           </a:xfrm>
           <a:prstGeom prst="rect">
             <a:avLst/>
@@ -5423,8 +5423,8 @@
         </p:nvSpPr>
         <p:spPr>
           <a:xfrm>
-            <a:off x="2663406" y="3625587"/>
-            <a:ext cx="9525" cy="1720412"/>
+            <a:off x="2686671" y="3769587"/>
+            <a:ext cx="9525" cy="1684412"/>
           </a:xfrm>
           <a:prstGeom prst="rect">
             <a:avLst/>
@@ -5467,8 +5467,8 @@
         </p:nvSpPr>
         <p:spPr>
           <a:xfrm>
-            <a:off x="2663406" y="5346000"/>
-            <a:ext cx="9525" cy="1720412"/>
+            <a:off x="2686671" y="5454000"/>
+            <a:ext cx="9525" cy="1684412"/>
           </a:xfrm>
           <a:prstGeom prst="rect">
             <a:avLst/>
@@ -5511,8 +5511,8 @@
         </p:nvSpPr>
         <p:spPr>
           <a:xfrm>
-            <a:off x="2663406" y="7066412"/>
-            <a:ext cx="9525" cy="1720412"/>
+            <a:off x="2686671" y="7138412"/>
+            <a:ext cx="9525" cy="1684412"/>
           </a:xfrm>
           <a:prstGeom prst="rect">
             <a:avLst/>
@@ -5555,8 +5555,8 @@
         </p:nvSpPr>
         <p:spPr>
           <a:xfrm>
-            <a:off x="2663406" y="8786825"/>
-            <a:ext cx="9525" cy="1720412"/>
+            <a:off x="2686671" y="8822825"/>
+            <a:ext cx="9525" cy="1684412"/>
           </a:xfrm>
           <a:prstGeom prst="rect">
             <a:avLst/>
@@ -5599,8 +5599,8 @@
         </p:nvSpPr>
         <p:spPr>
           <a:xfrm>
-            <a:off x="4887068" y="184762"/>
-            <a:ext cx="9525" cy="1720412"/>
+            <a:off x="4863803" y="400762"/>
+            <a:ext cx="9525" cy="1684412"/>
           </a:xfrm>
           <a:prstGeom prst="rect">
             <a:avLst/>
@@ -5643,8 +5643,8 @@
         </p:nvSpPr>
         <p:spPr>
           <a:xfrm>
-            <a:off x="4887068" y="1905175"/>
-            <a:ext cx="9525" cy="1720412"/>
+            <a:off x="4863803" y="2085175"/>
+            <a:ext cx="9525" cy="1684412"/>
           </a:xfrm>
           <a:prstGeom prst="rect">
             <a:avLst/>
@@ -5687,8 +5687,8 @@
         </p:nvSpPr>
         <p:spPr>
           <a:xfrm>
-            <a:off x="4887068" y="3625587"/>
-            <a:ext cx="9525" cy="1720412"/>
+            <a:off x="4863803" y="3769587"/>
+            <a:ext cx="9525" cy="1684412"/>
           </a:xfrm>
           <a:prstGeom prst="rect">
             <a:avLst/>
@@ -5731,8 +5731,8 @@
         </p:nvSpPr>
         <p:spPr>
           <a:xfrm>
-            <a:off x="4887068" y="5346000"/>
-            <a:ext cx="9525" cy="1720412"/>
+            <a:off x="4863803" y="5454000"/>
+            <a:ext cx="9525" cy="1684412"/>
           </a:xfrm>
           <a:prstGeom prst="rect">
             <a:avLst/>
@@ -5775,8 +5775,8 @@
         </p:nvSpPr>
         <p:spPr>
           <a:xfrm>
-            <a:off x="4887068" y="7066412"/>
-            <a:ext cx="9525" cy="1720412"/>
+            <a:off x="4863803" y="7138412"/>
+            <a:ext cx="9525" cy="1684412"/>
           </a:xfrm>
           <a:prstGeom prst="rect">
             <a:avLst/>
@@ -5819,8 +5819,8 @@
         </p:nvSpPr>
         <p:spPr>
           <a:xfrm>
-            <a:off x="4887068" y="8786825"/>
-            <a:ext cx="9525" cy="1720412"/>
+            <a:off x="4863803" y="8822825"/>
+            <a:ext cx="9525" cy="1684412"/>
           </a:xfrm>
           <a:prstGeom prst="rect">
             <a:avLst/>
@@ -5863,8 +5863,8 @@
         </p:nvSpPr>
         <p:spPr>
           <a:xfrm>
-            <a:off x="7110731" y="184762"/>
-            <a:ext cx="9525" cy="1720412"/>
+            <a:off x="7040935" y="400762"/>
+            <a:ext cx="9525" cy="1684412"/>
           </a:xfrm>
           <a:prstGeom prst="rect">
             <a:avLst/>
@@ -5907,8 +5907,8 @@
         </p:nvSpPr>
         <p:spPr>
           <a:xfrm>
-            <a:off x="7110731" y="1905175"/>
-            <a:ext cx="9525" cy="1720412"/>
+            <a:off x="7040935" y="2085175"/>
+            <a:ext cx="9525" cy="1684412"/>
           </a:xfrm>
           <a:prstGeom prst="rect">
             <a:avLst/>
@@ -5951,8 +5951,8 @@
         </p:nvSpPr>
         <p:spPr>
           <a:xfrm>
-            <a:off x="7110731" y="3625587"/>
-            <a:ext cx="9525" cy="1720412"/>
+            <a:off x="7040935" y="3769587"/>
+            <a:ext cx="9525" cy="1684412"/>
           </a:xfrm>
           <a:prstGeom prst="rect">
             <a:avLst/>
@@ -5995,8 +5995,8 @@
         </p:nvSpPr>
         <p:spPr>
           <a:xfrm>
-            <a:off x="7110731" y="5346000"/>
-            <a:ext cx="9525" cy="1720412"/>
+            <a:off x="7040935" y="5454000"/>
+            <a:ext cx="9525" cy="1684412"/>
           </a:xfrm>
           <a:prstGeom prst="rect">
             <a:avLst/>
@@ -6039,8 +6039,8 @@
         </p:nvSpPr>
         <p:spPr>
           <a:xfrm>
-            <a:off x="7110731" y="7066412"/>
-            <a:ext cx="9525" cy="1720412"/>
+            <a:off x="7040935" y="7138412"/>
+            <a:ext cx="9525" cy="1684412"/>
           </a:xfrm>
           <a:prstGeom prst="rect">
             <a:avLst/>
@@ -6083,8 +6083,8 @@
         </p:nvSpPr>
         <p:spPr>
           <a:xfrm>
-            <a:off x="7110731" y="8786825"/>
-            <a:ext cx="9525" cy="1720412"/>
+            <a:off x="7040935" y="8822825"/>
+            <a:ext cx="9525" cy="1684412"/>
           </a:xfrm>
           <a:prstGeom prst="rect">
             <a:avLst/>
@@ -6116,6 +6116,41 @@
           <a:lstStyle/>
           <a:p>
             <a:pPr algn="ctr"/>
+          </a:p>
+        </p:txBody>
+      </p:sp>
+      <p:sp>
+        <p:nvSpPr>
+          <p:cNvPr id="65" name="TextBox 64"/>
+          <p:cNvSpPr txBox="1"/>
+          <p:nvPr/>
+        </p:nvSpPr>
+        <p:spPr>
+          <a:xfrm>
+            <a:off x="184762" y="184762"/>
+            <a:ext cx="7190475" cy="198000"/>
+          </a:xfrm>
+          <a:prstGeom prst="rect">
+            <a:avLst/>
+          </a:prstGeom>
+          <a:noFill/>
+        </p:spPr>
+        <p:txBody>
+          <a:bodyPr wrap="none" lIns="0" rIns="0" tIns="0" bIns="0">
+            <a:spAutoFit/>
+          </a:bodyPr>
+          <a:lstStyle/>
+          <a:p>
+            <a:pPr algn="l"/>
+            <a:r>
+              <a:rPr sz="900" b="0">
+                <a:solidFill>
+                  <a:srgbClr val="555555"/>
+                </a:solidFill>
+                <a:latin typeface="Arial"/>
+              </a:rPr>
+              <a:t>Карты букв · ЛИЦО</a:t>
+            </a:r>
           </a:p>
         </p:txBody>
       </p:sp>
@@ -6145,8 +6180,8 @@
         </p:nvSpPr>
         <p:spPr>
           <a:xfrm>
-            <a:off x="4891831" y="184762"/>
-            <a:ext cx="2223662" cy="1720412"/>
+            <a:off x="4868565" y="400762"/>
+            <a:ext cx="2177131" cy="1684412"/>
           </a:xfrm>
           <a:prstGeom prst="rect">
             <a:avLst/>
@@ -6187,8 +6222,8 @@
         </p:nvSpPr>
         <p:spPr>
           <a:xfrm>
-            <a:off x="2668168" y="184762"/>
-            <a:ext cx="2223662" cy="1720412"/>
+            <a:off x="2691434" y="400762"/>
+            <a:ext cx="2177131" cy="1684412"/>
           </a:xfrm>
           <a:prstGeom prst="rect">
             <a:avLst/>
@@ -6229,8 +6264,8 @@
         </p:nvSpPr>
         <p:spPr>
           <a:xfrm>
-            <a:off x="444506" y="184762"/>
-            <a:ext cx="2223662" cy="1720412"/>
+            <a:off x="514302" y="400762"/>
+            <a:ext cx="2177131" cy="1684412"/>
           </a:xfrm>
           <a:prstGeom prst="rect">
             <a:avLst/>
@@ -6271,8 +6306,8 @@
         </p:nvSpPr>
         <p:spPr>
           <a:xfrm>
-            <a:off x="4891831" y="1905175"/>
-            <a:ext cx="2223662" cy="1720412"/>
+            <a:off x="4868565" y="2085175"/>
+            <a:ext cx="2177131" cy="1684412"/>
           </a:xfrm>
           <a:prstGeom prst="rect">
             <a:avLst/>
@@ -6313,8 +6348,8 @@
         </p:nvSpPr>
         <p:spPr>
           <a:xfrm>
-            <a:off x="2668168" y="1905175"/>
-            <a:ext cx="2223662" cy="1720412"/>
+            <a:off x="2691434" y="2085175"/>
+            <a:ext cx="2177131" cy="1684412"/>
           </a:xfrm>
           <a:prstGeom prst="rect">
             <a:avLst/>
@@ -6355,8 +6390,8 @@
         </p:nvSpPr>
         <p:spPr>
           <a:xfrm>
-            <a:off x="444506" y="1905175"/>
-            <a:ext cx="2223662" cy="1720412"/>
+            <a:off x="514302" y="2085175"/>
+            <a:ext cx="2177131" cy="1684412"/>
           </a:xfrm>
           <a:prstGeom prst="rect">
             <a:avLst/>
@@ -6397,8 +6432,8 @@
         </p:nvSpPr>
         <p:spPr>
           <a:xfrm>
-            <a:off x="4891831" y="3625587"/>
-            <a:ext cx="2223662" cy="1720412"/>
+            <a:off x="4868565" y="3769587"/>
+            <a:ext cx="2177131" cy="1684412"/>
           </a:xfrm>
           <a:prstGeom prst="rect">
             <a:avLst/>
@@ -6439,8 +6474,8 @@
         </p:nvSpPr>
         <p:spPr>
           <a:xfrm>
-            <a:off x="2668168" y="3625587"/>
-            <a:ext cx="2223662" cy="1720412"/>
+            <a:off x="2691434" y="3769587"/>
+            <a:ext cx="2177131" cy="1684412"/>
           </a:xfrm>
           <a:prstGeom prst="rect">
             <a:avLst/>
@@ -6481,8 +6516,8 @@
         </p:nvSpPr>
         <p:spPr>
           <a:xfrm>
-            <a:off x="444506" y="3625587"/>
-            <a:ext cx="2223662" cy="1720412"/>
+            <a:off x="514302" y="3769587"/>
+            <a:ext cx="2177131" cy="1684412"/>
           </a:xfrm>
           <a:prstGeom prst="rect">
             <a:avLst/>
@@ -6523,8 +6558,8 @@
         </p:nvSpPr>
         <p:spPr>
           <a:xfrm>
-            <a:off x="4891831" y="5346000"/>
-            <a:ext cx="2223662" cy="1720412"/>
+            <a:off x="4868565" y="5454000"/>
+            <a:ext cx="2177131" cy="1684412"/>
           </a:xfrm>
           <a:prstGeom prst="rect">
             <a:avLst/>
@@ -6565,8 +6600,8 @@
         </p:nvSpPr>
         <p:spPr>
           <a:xfrm>
-            <a:off x="2668168" y="5346000"/>
-            <a:ext cx="2223662" cy="1720412"/>
+            <a:off x="2691434" y="5454000"/>
+            <a:ext cx="2177131" cy="1684412"/>
           </a:xfrm>
           <a:prstGeom prst="rect">
             <a:avLst/>
@@ -6607,8 +6642,8 @@
         </p:nvSpPr>
         <p:spPr>
           <a:xfrm>
-            <a:off x="444506" y="5346000"/>
-            <a:ext cx="2223662" cy="1720412"/>
+            <a:off x="514302" y="5454000"/>
+            <a:ext cx="2177131" cy="1684412"/>
           </a:xfrm>
           <a:prstGeom prst="rect">
             <a:avLst/>
@@ -6649,8 +6684,8 @@
         </p:nvSpPr>
         <p:spPr>
           <a:xfrm>
-            <a:off x="4891831" y="7066412"/>
-            <a:ext cx="2223662" cy="1720412"/>
+            <a:off x="4868565" y="7138412"/>
+            <a:ext cx="2177131" cy="1684412"/>
           </a:xfrm>
           <a:prstGeom prst="rect">
             <a:avLst/>
@@ -6691,8 +6726,8 @@
         </p:nvSpPr>
         <p:spPr>
           <a:xfrm>
-            <a:off x="2668168" y="7066412"/>
-            <a:ext cx="2223662" cy="1720412"/>
+            <a:off x="2691434" y="7138412"/>
+            <a:ext cx="2177131" cy="1684412"/>
           </a:xfrm>
           <a:prstGeom prst="rect">
             <a:avLst/>
@@ -6733,8 +6768,8 @@
         </p:nvSpPr>
         <p:spPr>
           <a:xfrm>
-            <a:off x="444506" y="7066412"/>
-            <a:ext cx="2223662" cy="1720412"/>
+            <a:off x="514302" y="7138412"/>
+            <a:ext cx="2177131" cy="1684412"/>
           </a:xfrm>
           <a:prstGeom prst="rect">
             <a:avLst/>
@@ -6775,8 +6810,8 @@
         </p:nvSpPr>
         <p:spPr>
           <a:xfrm>
-            <a:off x="4891831" y="8786825"/>
-            <a:ext cx="2223662" cy="1720412"/>
+            <a:off x="4868565" y="8822825"/>
+            <a:ext cx="2177131" cy="1684412"/>
           </a:xfrm>
           <a:prstGeom prst="rect">
             <a:avLst/>
@@ -6817,8 +6852,8 @@
         </p:nvSpPr>
         <p:spPr>
           <a:xfrm>
-            <a:off x="2668168" y="8786825"/>
-            <a:ext cx="2223662" cy="1720412"/>
+            <a:off x="2691434" y="8822825"/>
+            <a:ext cx="2177131" cy="1684412"/>
           </a:xfrm>
           <a:prstGeom prst="rect">
             <a:avLst/>
@@ -6859,8 +6894,8 @@
         </p:nvSpPr>
         <p:spPr>
           <a:xfrm>
-            <a:off x="444506" y="8786825"/>
-            <a:ext cx="2223662" cy="1720412"/>
+            <a:off x="514302" y="8822825"/>
+            <a:ext cx="2177131" cy="1684412"/>
           </a:xfrm>
           <a:prstGeom prst="rect">
             <a:avLst/>
@@ -6890,6 +6925,41 @@
           <a:lstStyle/>
           <a:p>
             <a:pPr algn="ctr"/>
+          </a:p>
+        </p:txBody>
+      </p:sp>
+      <p:sp>
+        <p:nvSpPr>
+          <p:cNvPr id="20" name="TextBox 19"/>
+          <p:cNvSpPr txBox="1"/>
+          <p:nvPr/>
+        </p:nvSpPr>
+        <p:spPr>
+          <a:xfrm>
+            <a:off x="184762" y="184762"/>
+            <a:ext cx="7190475" cy="198000"/>
+          </a:xfrm>
+          <a:prstGeom prst="rect">
+            <a:avLst/>
+          </a:prstGeom>
+          <a:noFill/>
+        </p:spPr>
+        <p:txBody>
+          <a:bodyPr wrap="none" lIns="0" rIns="0" tIns="0" bIns="0">
+            <a:spAutoFit/>
+          </a:bodyPr>
+          <a:lstStyle/>
+          <a:p>
+            <a:pPr algn="l"/>
+            <a:r>
+              <a:rPr sz="900" b="0">
+                <a:solidFill>
+                  <a:srgbClr val="555555"/>
+                </a:solidFill>
+                <a:latin typeface="Arial"/>
+              </a:rPr>
+              <a:t>Карты букв · ОБОРОТ</a:t>
+            </a:r>
           </a:p>
         </p:txBody>
       </p:sp>
@@ -6919,8 +6989,8 @@
         </p:nvSpPr>
         <p:spPr>
           <a:xfrm>
-            <a:off x="444506" y="184762"/>
-            <a:ext cx="2223662" cy="1720412"/>
+            <a:off x="514302" y="400762"/>
+            <a:ext cx="2177131" cy="1684412"/>
           </a:xfrm>
           <a:prstGeom prst="rect">
             <a:avLst/>
@@ -6946,7 +7016,7 @@
           </a:fontRef>
         </p:style>
         <p:txBody>
-          <a:bodyPr rtlCol="0" anchor="ctr" wrap="none" lIns="58517" rIns="58517" tIns="39011" bIns="39011"/>
+          <a:bodyPr rtlCol="0" anchor="ctr" wrap="none" lIns="57292" rIns="57292" tIns="38195" bIns="38195"/>
           <a:lstStyle/>
           <a:p>
             <a:pPr algn="ctr">
@@ -6977,8 +7047,8 @@
         </p:nvSpPr>
         <p:spPr>
           <a:xfrm>
-            <a:off x="2668168" y="184762"/>
-            <a:ext cx="2223662" cy="1720412"/>
+            <a:off x="2691434" y="400762"/>
+            <a:ext cx="2177131" cy="1684412"/>
           </a:xfrm>
           <a:prstGeom prst="rect">
             <a:avLst/>
@@ -7004,7 +7074,7 @@
           </a:fontRef>
         </p:style>
         <p:txBody>
-          <a:bodyPr rtlCol="0" anchor="ctr" wrap="none" lIns="58517" rIns="58517" tIns="39011" bIns="39011"/>
+          <a:bodyPr rtlCol="0" anchor="ctr" wrap="none" lIns="57292" rIns="57292" tIns="38195" bIns="38195"/>
           <a:lstStyle/>
           <a:p>
             <a:pPr algn="ctr">
@@ -7035,8 +7105,8 @@
         </p:nvSpPr>
         <p:spPr>
           <a:xfrm>
-            <a:off x="4891831" y="184762"/>
-            <a:ext cx="2223662" cy="1720412"/>
+            <a:off x="4868565" y="400762"/>
+            <a:ext cx="2177131" cy="1684412"/>
           </a:xfrm>
           <a:prstGeom prst="rect">
             <a:avLst/>
@@ -7062,7 +7132,7 @@
           </a:fontRef>
         </p:style>
         <p:txBody>
-          <a:bodyPr rtlCol="0" anchor="ctr" wrap="none" lIns="58517" rIns="58517" tIns="39011" bIns="39011"/>
+          <a:bodyPr rtlCol="0" anchor="ctr" wrap="none" lIns="57292" rIns="57292" tIns="38195" bIns="38195"/>
           <a:lstStyle/>
           <a:p>
             <a:pPr algn="ctr">
@@ -7093,8 +7163,8 @@
         </p:nvSpPr>
         <p:spPr>
           <a:xfrm>
-            <a:off x="444506" y="1905175"/>
-            <a:ext cx="2223662" cy="1720412"/>
+            <a:off x="514302" y="2085175"/>
+            <a:ext cx="2177131" cy="1684412"/>
           </a:xfrm>
           <a:prstGeom prst="rect">
             <a:avLst/>
@@ -7120,7 +7190,7 @@
           </a:fontRef>
         </p:style>
         <p:txBody>
-          <a:bodyPr rtlCol="0" anchor="ctr" wrap="none" lIns="58517" rIns="58517" tIns="39011" bIns="39011"/>
+          <a:bodyPr rtlCol="0" anchor="ctr" wrap="none" lIns="57292" rIns="57292" tIns="38195" bIns="38195"/>
           <a:lstStyle/>
           <a:p>
             <a:pPr algn="ctr">
@@ -7151,8 +7221,8 @@
         </p:nvSpPr>
         <p:spPr>
           <a:xfrm>
-            <a:off x="2668168" y="1905175"/>
-            <a:ext cx="2223662" cy="1720412"/>
+            <a:off x="2691434" y="2085175"/>
+            <a:ext cx="2177131" cy="1684412"/>
           </a:xfrm>
           <a:prstGeom prst="rect">
             <a:avLst/>
@@ -7178,7 +7248,7 @@
           </a:fontRef>
         </p:style>
         <p:txBody>
-          <a:bodyPr rtlCol="0" anchor="ctr" wrap="none" lIns="58517" rIns="58517" tIns="39011" bIns="39011"/>
+          <a:bodyPr rtlCol="0" anchor="ctr" wrap="none" lIns="57292" rIns="57292" tIns="38195" bIns="38195"/>
           <a:lstStyle/>
           <a:p>
             <a:pPr algn="ctr">
@@ -7209,8 +7279,8 @@
         </p:nvSpPr>
         <p:spPr>
           <a:xfrm>
-            <a:off x="4891831" y="1905175"/>
-            <a:ext cx="2223662" cy="1720412"/>
+            <a:off x="4868565" y="2085175"/>
+            <a:ext cx="2177131" cy="1684412"/>
           </a:xfrm>
           <a:prstGeom prst="rect">
             <a:avLst/>
@@ -7236,7 +7306,7 @@
           </a:fontRef>
         </p:style>
         <p:txBody>
-          <a:bodyPr rtlCol="0" anchor="ctr" wrap="none" lIns="58517" rIns="58517" tIns="39011" bIns="39011"/>
+          <a:bodyPr rtlCol="0" anchor="ctr" wrap="none" lIns="57292" rIns="57292" tIns="38195" bIns="38195"/>
           <a:lstStyle/>
           <a:p>
             <a:pPr algn="ctr">
@@ -7267,8 +7337,8 @@
         </p:nvSpPr>
         <p:spPr>
           <a:xfrm>
-            <a:off x="444506" y="3625587"/>
-            <a:ext cx="2223662" cy="1720412"/>
+            <a:off x="514302" y="3769587"/>
+            <a:ext cx="2177131" cy="1684412"/>
           </a:xfrm>
           <a:prstGeom prst="rect">
             <a:avLst/>
@@ -7294,7 +7364,7 @@
           </a:fontRef>
         </p:style>
         <p:txBody>
-          <a:bodyPr rtlCol="0" anchor="ctr" wrap="none" lIns="58517" rIns="58517" tIns="39011" bIns="39011"/>
+          <a:bodyPr rtlCol="0" anchor="ctr" wrap="none" lIns="57292" rIns="57292" tIns="38195" bIns="38195"/>
           <a:lstStyle/>
           <a:p>
             <a:pPr algn="ctr">
@@ -7325,8 +7395,8 @@
         </p:nvSpPr>
         <p:spPr>
           <a:xfrm>
-            <a:off x="2668168" y="3625587"/>
-            <a:ext cx="2223662" cy="1720412"/>
+            <a:off x="2691434" y="3769587"/>
+            <a:ext cx="2177131" cy="1684412"/>
           </a:xfrm>
           <a:prstGeom prst="rect">
             <a:avLst/>
@@ -7352,7 +7422,7 @@
           </a:fontRef>
         </p:style>
         <p:txBody>
-          <a:bodyPr rtlCol="0" anchor="ctr" wrap="none" lIns="58517" rIns="58517" tIns="39011" bIns="39011"/>
+          <a:bodyPr rtlCol="0" anchor="ctr" wrap="none" lIns="57292" rIns="57292" tIns="38195" bIns="38195"/>
           <a:lstStyle/>
           <a:p>
             <a:pPr algn="ctr">
@@ -7383,8 +7453,8 @@
         </p:nvSpPr>
         <p:spPr>
           <a:xfrm>
-            <a:off x="4891831" y="3625587"/>
-            <a:ext cx="2223662" cy="1720412"/>
+            <a:off x="4868565" y="3769587"/>
+            <a:ext cx="2177131" cy="1684412"/>
           </a:xfrm>
           <a:prstGeom prst="rect">
             <a:avLst/>
@@ -7410,7 +7480,7 @@
           </a:fontRef>
         </p:style>
         <p:txBody>
-          <a:bodyPr rtlCol="0" anchor="ctr" wrap="none" lIns="58517" rIns="58517" tIns="39011" bIns="39011"/>
+          <a:bodyPr rtlCol="0" anchor="ctr" wrap="none" lIns="57292" rIns="57292" tIns="38195" bIns="38195"/>
           <a:lstStyle/>
           <a:p>
             <a:pPr algn="ctr">
@@ -7441,8 +7511,8 @@
         </p:nvSpPr>
         <p:spPr>
           <a:xfrm>
-            <a:off x="444506" y="5346000"/>
-            <a:ext cx="2223662" cy="1720412"/>
+            <a:off x="514302" y="5454000"/>
+            <a:ext cx="2177131" cy="1684412"/>
           </a:xfrm>
           <a:prstGeom prst="rect">
             <a:avLst/>
@@ -7468,7 +7538,7 @@
           </a:fontRef>
         </p:style>
         <p:txBody>
-          <a:bodyPr rtlCol="0" anchor="ctr" wrap="none" lIns="58517" rIns="58517" tIns="39011" bIns="39011"/>
+          <a:bodyPr rtlCol="0" anchor="ctr" wrap="none" lIns="57292" rIns="57292" tIns="38195" bIns="38195"/>
           <a:lstStyle/>
           <a:p>
             <a:pPr algn="ctr">
@@ -7499,8 +7569,8 @@
         </p:nvSpPr>
         <p:spPr>
           <a:xfrm>
-            <a:off x="2668168" y="5346000"/>
-            <a:ext cx="2223662" cy="1720412"/>
+            <a:off x="2691434" y="5454000"/>
+            <a:ext cx="2177131" cy="1684412"/>
           </a:xfrm>
           <a:prstGeom prst="rect">
             <a:avLst/>
@@ -7526,7 +7596,7 @@
           </a:fontRef>
         </p:style>
         <p:txBody>
-          <a:bodyPr rtlCol="0" anchor="ctr" wrap="none" lIns="58517" rIns="58517" tIns="39011" bIns="39011"/>
+          <a:bodyPr rtlCol="0" anchor="ctr" wrap="none" lIns="57292" rIns="57292" tIns="38195" bIns="38195"/>
           <a:lstStyle/>
           <a:p>
             <a:pPr algn="ctr">
@@ -7557,8 +7627,8 @@
         </p:nvSpPr>
         <p:spPr>
           <a:xfrm>
-            <a:off x="4891831" y="5346000"/>
-            <a:ext cx="2223662" cy="1720412"/>
+            <a:off x="4868565" y="5454000"/>
+            <a:ext cx="2177131" cy="1684412"/>
           </a:xfrm>
           <a:prstGeom prst="rect">
             <a:avLst/>
@@ -7584,7 +7654,7 @@
           </a:fontRef>
         </p:style>
         <p:txBody>
-          <a:bodyPr rtlCol="0" anchor="ctr" wrap="none" lIns="58517" rIns="58517" tIns="39011" bIns="39011"/>
+          <a:bodyPr rtlCol="0" anchor="ctr" wrap="none" lIns="57292" rIns="57292" tIns="38195" bIns="38195"/>
           <a:lstStyle/>
           <a:p>
             <a:pPr algn="ctr">
@@ -7615,8 +7685,8 @@
         </p:nvSpPr>
         <p:spPr>
           <a:xfrm>
-            <a:off x="444506" y="7066412"/>
-            <a:ext cx="2223662" cy="1720412"/>
+            <a:off x="514302" y="7138412"/>
+            <a:ext cx="2177131" cy="1684412"/>
           </a:xfrm>
           <a:prstGeom prst="rect">
             <a:avLst/>
@@ -7642,7 +7712,7 @@
           </a:fontRef>
         </p:style>
         <p:txBody>
-          <a:bodyPr rtlCol="0" anchor="ctr" wrap="none" lIns="58517" rIns="58517" tIns="39011" bIns="39011"/>
+          <a:bodyPr rtlCol="0" anchor="ctr" wrap="none" lIns="57292" rIns="57292" tIns="38195" bIns="38195"/>
           <a:lstStyle/>
           <a:p>
             <a:pPr algn="ctr">
@@ -7673,8 +7743,8 @@
         </p:nvSpPr>
         <p:spPr>
           <a:xfrm>
-            <a:off x="2668168" y="7066412"/>
-            <a:ext cx="2223662" cy="1720412"/>
+            <a:off x="2691434" y="7138412"/>
+            <a:ext cx="2177131" cy="1684412"/>
           </a:xfrm>
           <a:prstGeom prst="rect">
             <a:avLst/>
@@ -7700,7 +7770,7 @@
           </a:fontRef>
         </p:style>
         <p:txBody>
-          <a:bodyPr rtlCol="0" anchor="ctr" wrap="none" lIns="58517" rIns="58517" tIns="39011" bIns="39011"/>
+          <a:bodyPr rtlCol="0" anchor="ctr" wrap="none" lIns="57292" rIns="57292" tIns="38195" bIns="38195"/>
           <a:lstStyle/>
           <a:p>
             <a:pPr algn="ctr">
@@ -7731,8 +7801,8 @@
         </p:nvSpPr>
         <p:spPr>
           <a:xfrm>
-            <a:off x="4891831" y="7066412"/>
-            <a:ext cx="2223662" cy="1720412"/>
+            <a:off x="4868565" y="7138412"/>
+            <a:ext cx="2177131" cy="1684412"/>
           </a:xfrm>
           <a:prstGeom prst="rect">
             <a:avLst/>
@@ -7758,7 +7828,7 @@
           </a:fontRef>
         </p:style>
         <p:txBody>
-          <a:bodyPr rtlCol="0" anchor="ctr" wrap="none" lIns="58517" rIns="58517" tIns="39011" bIns="39011"/>
+          <a:bodyPr rtlCol="0" anchor="ctr" wrap="none" lIns="57292" rIns="57292" tIns="38195" bIns="38195"/>
           <a:lstStyle/>
           <a:p>
             <a:pPr algn="ctr">
@@ -7789,8 +7859,8 @@
         </p:nvSpPr>
         <p:spPr>
           <a:xfrm>
-            <a:off x="444506" y="8786825"/>
-            <a:ext cx="2223662" cy="1720412"/>
+            <a:off x="514302" y="8822825"/>
+            <a:ext cx="2177131" cy="1684412"/>
           </a:xfrm>
           <a:prstGeom prst="rect">
             <a:avLst/>
@@ -7816,7 +7886,7 @@
           </a:fontRef>
         </p:style>
         <p:txBody>
-          <a:bodyPr rtlCol="0" anchor="ctr" wrap="none" lIns="58517" rIns="58517" tIns="39011" bIns="39011"/>
+          <a:bodyPr rtlCol="0" anchor="ctr" wrap="none" lIns="57292" rIns="57292" tIns="38195" bIns="38195"/>
           <a:lstStyle/>
           <a:p>
             <a:pPr algn="ctr">
@@ -7847,8 +7917,8 @@
         </p:nvSpPr>
         <p:spPr>
           <a:xfrm>
-            <a:off x="2668168" y="8786825"/>
-            <a:ext cx="2223662" cy="1720412"/>
+            <a:off x="2691434" y="8822825"/>
+            <a:ext cx="2177131" cy="1684412"/>
           </a:xfrm>
           <a:prstGeom prst="rect">
             <a:avLst/>
@@ -7874,7 +7944,7 @@
           </a:fontRef>
         </p:style>
         <p:txBody>
-          <a:bodyPr rtlCol="0" anchor="ctr" wrap="none" lIns="58517" rIns="58517" tIns="39011" bIns="39011"/>
+          <a:bodyPr rtlCol="0" anchor="ctr" wrap="none" lIns="57292" rIns="57292" tIns="38195" bIns="38195"/>
           <a:lstStyle/>
           <a:p>
             <a:pPr algn="ctr">
@@ -7905,8 +7975,8 @@
         </p:nvSpPr>
         <p:spPr>
           <a:xfrm>
-            <a:off x="4891831" y="8786825"/>
-            <a:ext cx="2223662" cy="1720412"/>
+            <a:off x="4868565" y="8822825"/>
+            <a:ext cx="2177131" cy="1684412"/>
           </a:xfrm>
           <a:prstGeom prst="rect">
             <a:avLst/>
@@ -7932,7 +8002,7 @@
           </a:fontRef>
         </p:style>
         <p:txBody>
-          <a:bodyPr rtlCol="0" anchor="ctr" wrap="none" lIns="58517" rIns="58517" tIns="39011" bIns="39011"/>
+          <a:bodyPr rtlCol="0" anchor="ctr" wrap="none" lIns="57292" rIns="57292" tIns="38195" bIns="38195"/>
           <a:lstStyle/>
           <a:p>
             <a:pPr algn="ctr">
@@ -7963,8 +8033,8 @@
         </p:nvSpPr>
         <p:spPr>
           <a:xfrm>
-            <a:off x="444506" y="180000"/>
-            <a:ext cx="2223662" cy="9525"/>
+            <a:off x="514302" y="396000"/>
+            <a:ext cx="2177131" cy="9525"/>
           </a:xfrm>
           <a:prstGeom prst="rect">
             <a:avLst/>
@@ -8007,8 +8077,8 @@
         </p:nvSpPr>
         <p:spPr>
           <a:xfrm>
-            <a:off x="2668168" y="180000"/>
-            <a:ext cx="2223662" cy="9525"/>
+            <a:off x="2691434" y="396000"/>
+            <a:ext cx="2177131" cy="9525"/>
           </a:xfrm>
           <a:prstGeom prst="rect">
             <a:avLst/>
@@ -8051,8 +8121,8 @@
         </p:nvSpPr>
         <p:spPr>
           <a:xfrm>
-            <a:off x="4891831" y="180000"/>
-            <a:ext cx="2223662" cy="9525"/>
+            <a:off x="4868565" y="396000"/>
+            <a:ext cx="2177131" cy="9525"/>
           </a:xfrm>
           <a:prstGeom prst="rect">
             <a:avLst/>
@@ -8095,8 +8165,8 @@
         </p:nvSpPr>
         <p:spPr>
           <a:xfrm>
-            <a:off x="444506" y="1900412"/>
-            <a:ext cx="2223662" cy="9525"/>
+            <a:off x="514302" y="2080412"/>
+            <a:ext cx="2177131" cy="9525"/>
           </a:xfrm>
           <a:prstGeom prst="rect">
             <a:avLst/>
@@ -8139,8 +8209,8 @@
         </p:nvSpPr>
         <p:spPr>
           <a:xfrm>
-            <a:off x="2668168" y="1900412"/>
-            <a:ext cx="2223662" cy="9525"/>
+            <a:off x="2691434" y="2080412"/>
+            <a:ext cx="2177131" cy="9525"/>
           </a:xfrm>
           <a:prstGeom prst="rect">
             <a:avLst/>
@@ -8183,8 +8253,8 @@
         </p:nvSpPr>
         <p:spPr>
           <a:xfrm>
-            <a:off x="4891831" y="1900412"/>
-            <a:ext cx="2223662" cy="9525"/>
+            <a:off x="4868565" y="2080412"/>
+            <a:ext cx="2177131" cy="9525"/>
           </a:xfrm>
           <a:prstGeom prst="rect">
             <a:avLst/>
@@ -8227,8 +8297,8 @@
         </p:nvSpPr>
         <p:spPr>
           <a:xfrm>
-            <a:off x="444506" y="3620825"/>
-            <a:ext cx="2223662" cy="9525"/>
+            <a:off x="514302" y="3764825"/>
+            <a:ext cx="2177131" cy="9525"/>
           </a:xfrm>
           <a:prstGeom prst="rect">
             <a:avLst/>
@@ -8271,8 +8341,8 @@
         </p:nvSpPr>
         <p:spPr>
           <a:xfrm>
-            <a:off x="2668168" y="3620825"/>
-            <a:ext cx="2223662" cy="9525"/>
+            <a:off x="2691434" y="3764825"/>
+            <a:ext cx="2177131" cy="9525"/>
           </a:xfrm>
           <a:prstGeom prst="rect">
             <a:avLst/>
@@ -8315,8 +8385,8 @@
         </p:nvSpPr>
         <p:spPr>
           <a:xfrm>
-            <a:off x="4891831" y="3620825"/>
-            <a:ext cx="2223662" cy="9525"/>
+            <a:off x="4868565" y="3764825"/>
+            <a:ext cx="2177131" cy="9525"/>
           </a:xfrm>
           <a:prstGeom prst="rect">
             <a:avLst/>
@@ -8359,8 +8429,8 @@
         </p:nvSpPr>
         <p:spPr>
           <a:xfrm>
-            <a:off x="444506" y="5341237"/>
-            <a:ext cx="2223662" cy="9525"/>
+            <a:off x="514302" y="5449237"/>
+            <a:ext cx="2177131" cy="9525"/>
           </a:xfrm>
           <a:prstGeom prst="rect">
             <a:avLst/>
@@ -8403,8 +8473,8 @@
         </p:nvSpPr>
         <p:spPr>
           <a:xfrm>
-            <a:off x="2668168" y="5341237"/>
-            <a:ext cx="2223662" cy="9525"/>
+            <a:off x="2691434" y="5449237"/>
+            <a:ext cx="2177131" cy="9525"/>
           </a:xfrm>
           <a:prstGeom prst="rect">
             <a:avLst/>
@@ -8447,8 +8517,8 @@
         </p:nvSpPr>
         <p:spPr>
           <a:xfrm>
-            <a:off x="4891831" y="5341237"/>
-            <a:ext cx="2223662" cy="9525"/>
+            <a:off x="4868565" y="5449237"/>
+            <a:ext cx="2177131" cy="9525"/>
           </a:xfrm>
           <a:prstGeom prst="rect">
             <a:avLst/>
@@ -8491,8 +8561,8 @@
         </p:nvSpPr>
         <p:spPr>
           <a:xfrm>
-            <a:off x="444506" y="7061650"/>
-            <a:ext cx="2223662" cy="9525"/>
+            <a:off x="514302" y="7133650"/>
+            <a:ext cx="2177131" cy="9525"/>
           </a:xfrm>
           <a:prstGeom prst="rect">
             <a:avLst/>
@@ -8535,8 +8605,8 @@
         </p:nvSpPr>
         <p:spPr>
           <a:xfrm>
-            <a:off x="2668168" y="7061650"/>
-            <a:ext cx="2223662" cy="9525"/>
+            <a:off x="2691434" y="7133650"/>
+            <a:ext cx="2177131" cy="9525"/>
           </a:xfrm>
           <a:prstGeom prst="rect">
             <a:avLst/>
@@ -8579,8 +8649,8 @@
         </p:nvSpPr>
         <p:spPr>
           <a:xfrm>
-            <a:off x="4891831" y="7061650"/>
-            <a:ext cx="2223662" cy="9525"/>
+            <a:off x="4868565" y="7133650"/>
+            <a:ext cx="2177131" cy="9525"/>
           </a:xfrm>
           <a:prstGeom prst="rect">
             <a:avLst/>
@@ -8623,8 +8693,8 @@
         </p:nvSpPr>
         <p:spPr>
           <a:xfrm>
-            <a:off x="444506" y="8782062"/>
-            <a:ext cx="2223662" cy="9525"/>
+            <a:off x="514302" y="8818062"/>
+            <a:ext cx="2177131" cy="9525"/>
           </a:xfrm>
           <a:prstGeom prst="rect">
             <a:avLst/>
@@ -8667,8 +8737,8 @@
         </p:nvSpPr>
         <p:spPr>
           <a:xfrm>
-            <a:off x="2668168" y="8782062"/>
-            <a:ext cx="2223662" cy="9525"/>
+            <a:off x="2691434" y="8818062"/>
+            <a:ext cx="2177131" cy="9525"/>
           </a:xfrm>
           <a:prstGeom prst="rect">
             <a:avLst/>
@@ -8711,8 +8781,8 @@
         </p:nvSpPr>
         <p:spPr>
           <a:xfrm>
-            <a:off x="4891831" y="8782062"/>
-            <a:ext cx="2223662" cy="9525"/>
+            <a:off x="4868565" y="8818062"/>
+            <a:ext cx="2177131" cy="9525"/>
           </a:xfrm>
           <a:prstGeom prst="rect">
             <a:avLst/>
@@ -8755,8 +8825,8 @@
         </p:nvSpPr>
         <p:spPr>
           <a:xfrm>
-            <a:off x="444506" y="10502475"/>
-            <a:ext cx="2223662" cy="9525"/>
+            <a:off x="514302" y="10502475"/>
+            <a:ext cx="2177131" cy="9525"/>
           </a:xfrm>
           <a:prstGeom prst="rect">
             <a:avLst/>
@@ -8799,8 +8869,8 @@
         </p:nvSpPr>
         <p:spPr>
           <a:xfrm>
-            <a:off x="2668168" y="10502475"/>
-            <a:ext cx="2223662" cy="9525"/>
+            <a:off x="2691434" y="10502475"/>
+            <a:ext cx="2177131" cy="9525"/>
           </a:xfrm>
           <a:prstGeom prst="rect">
             <a:avLst/>
@@ -8843,8 +8913,8 @@
         </p:nvSpPr>
         <p:spPr>
           <a:xfrm>
-            <a:off x="4891831" y="10502475"/>
-            <a:ext cx="2223662" cy="9525"/>
+            <a:off x="4868565" y="10502475"/>
+            <a:ext cx="2177131" cy="9525"/>
           </a:xfrm>
           <a:prstGeom prst="rect">
             <a:avLst/>
@@ -8887,8 +8957,8 @@
         </p:nvSpPr>
         <p:spPr>
           <a:xfrm>
-            <a:off x="439743" y="184762"/>
-            <a:ext cx="9525" cy="1720412"/>
+            <a:off x="509539" y="400762"/>
+            <a:ext cx="9525" cy="1684412"/>
           </a:xfrm>
           <a:prstGeom prst="rect">
             <a:avLst/>
@@ -8931,8 +9001,8 @@
         </p:nvSpPr>
         <p:spPr>
           <a:xfrm>
-            <a:off x="439743" y="1905175"/>
-            <a:ext cx="9525" cy="1720412"/>
+            <a:off x="509539" y="2085175"/>
+            <a:ext cx="9525" cy="1684412"/>
           </a:xfrm>
           <a:prstGeom prst="rect">
             <a:avLst/>
@@ -8975,8 +9045,8 @@
         </p:nvSpPr>
         <p:spPr>
           <a:xfrm>
-            <a:off x="439743" y="3625587"/>
-            <a:ext cx="9525" cy="1720412"/>
+            <a:off x="509539" y="3769587"/>
+            <a:ext cx="9525" cy="1684412"/>
           </a:xfrm>
           <a:prstGeom prst="rect">
             <a:avLst/>
@@ -9019,8 +9089,8 @@
         </p:nvSpPr>
         <p:spPr>
           <a:xfrm>
-            <a:off x="439743" y="5346000"/>
-            <a:ext cx="9525" cy="1720412"/>
+            <a:off x="509539" y="5454000"/>
+            <a:ext cx="9525" cy="1684412"/>
           </a:xfrm>
           <a:prstGeom prst="rect">
             <a:avLst/>
@@ -9063,8 +9133,8 @@
         </p:nvSpPr>
         <p:spPr>
           <a:xfrm>
-            <a:off x="439743" y="7066412"/>
-            <a:ext cx="9525" cy="1720412"/>
+            <a:off x="509539" y="7138412"/>
+            <a:ext cx="9525" cy="1684412"/>
           </a:xfrm>
           <a:prstGeom prst="rect">
             <a:avLst/>
@@ -9107,8 +9177,8 @@
         </p:nvSpPr>
         <p:spPr>
           <a:xfrm>
-            <a:off x="439743" y="8786825"/>
-            <a:ext cx="9525" cy="1720412"/>
+            <a:off x="509539" y="8822825"/>
+            <a:ext cx="9525" cy="1684412"/>
           </a:xfrm>
           <a:prstGeom prst="rect">
             <a:avLst/>
@@ -9151,8 +9221,8 @@
         </p:nvSpPr>
         <p:spPr>
           <a:xfrm>
-            <a:off x="2663406" y="184762"/>
-            <a:ext cx="9525" cy="1720412"/>
+            <a:off x="2686671" y="400762"/>
+            <a:ext cx="9525" cy="1684412"/>
           </a:xfrm>
           <a:prstGeom prst="rect">
             <a:avLst/>
@@ -9195,8 +9265,8 @@
         </p:nvSpPr>
         <p:spPr>
           <a:xfrm>
-            <a:off x="2663406" y="1905175"/>
-            <a:ext cx="9525" cy="1720412"/>
+            <a:off x="2686671" y="2085175"/>
+            <a:ext cx="9525" cy="1684412"/>
           </a:xfrm>
           <a:prstGeom prst="rect">
             <a:avLst/>
@@ -9239,8 +9309,8 @@
         </p:nvSpPr>
         <p:spPr>
           <a:xfrm>
-            <a:off x="2663406" y="3625587"/>
-            <a:ext cx="9525" cy="1720412"/>
+            <a:off x="2686671" y="3769587"/>
+            <a:ext cx="9525" cy="1684412"/>
           </a:xfrm>
           <a:prstGeom prst="rect">
             <a:avLst/>
@@ -9283,8 +9353,8 @@
         </p:nvSpPr>
         <p:spPr>
           <a:xfrm>
-            <a:off x="2663406" y="5346000"/>
-            <a:ext cx="9525" cy="1720412"/>
+            <a:off x="2686671" y="5454000"/>
+            <a:ext cx="9525" cy="1684412"/>
           </a:xfrm>
           <a:prstGeom prst="rect">
             <a:avLst/>
@@ -9327,8 +9397,8 @@
         </p:nvSpPr>
         <p:spPr>
           <a:xfrm>
-            <a:off x="2663406" y="7066412"/>
-            <a:ext cx="9525" cy="1720412"/>
+            <a:off x="2686671" y="7138412"/>
+            <a:ext cx="9525" cy="1684412"/>
           </a:xfrm>
           <a:prstGeom prst="rect">
             <a:avLst/>
@@ -9371,8 +9441,8 @@
         </p:nvSpPr>
         <p:spPr>
           <a:xfrm>
-            <a:off x="2663406" y="8786825"/>
-            <a:ext cx="9525" cy="1720412"/>
+            <a:off x="2686671" y="8822825"/>
+            <a:ext cx="9525" cy="1684412"/>
           </a:xfrm>
           <a:prstGeom prst="rect">
             <a:avLst/>
@@ -9415,8 +9485,8 @@
         </p:nvSpPr>
         <p:spPr>
           <a:xfrm>
-            <a:off x="4887068" y="184762"/>
-            <a:ext cx="9525" cy="1720412"/>
+            <a:off x="4863803" y="400762"/>
+            <a:ext cx="9525" cy="1684412"/>
           </a:xfrm>
           <a:prstGeom prst="rect">
             <a:avLst/>
@@ -9459,8 +9529,8 @@
         </p:nvSpPr>
         <p:spPr>
           <a:xfrm>
-            <a:off x="4887068" y="1905175"/>
-            <a:ext cx="9525" cy="1720412"/>
+            <a:off x="4863803" y="2085175"/>
+            <a:ext cx="9525" cy="1684412"/>
           </a:xfrm>
           <a:prstGeom prst="rect">
             <a:avLst/>
@@ -9503,8 +9573,8 @@
         </p:nvSpPr>
         <p:spPr>
           <a:xfrm>
-            <a:off x="4887068" y="3625587"/>
-            <a:ext cx="9525" cy="1720412"/>
+            <a:off x="4863803" y="3769587"/>
+            <a:ext cx="9525" cy="1684412"/>
           </a:xfrm>
           <a:prstGeom prst="rect">
             <a:avLst/>
@@ -9547,8 +9617,8 @@
         </p:nvSpPr>
         <p:spPr>
           <a:xfrm>
-            <a:off x="4887068" y="5346000"/>
-            <a:ext cx="9525" cy="1720412"/>
+            <a:off x="4863803" y="5454000"/>
+            <a:ext cx="9525" cy="1684412"/>
           </a:xfrm>
           <a:prstGeom prst="rect">
             <a:avLst/>
@@ -9591,8 +9661,8 @@
         </p:nvSpPr>
         <p:spPr>
           <a:xfrm>
-            <a:off x="4887068" y="7066412"/>
-            <a:ext cx="9525" cy="1720412"/>
+            <a:off x="4863803" y="7138412"/>
+            <a:ext cx="9525" cy="1684412"/>
           </a:xfrm>
           <a:prstGeom prst="rect">
             <a:avLst/>
@@ -9635,8 +9705,8 @@
         </p:nvSpPr>
         <p:spPr>
           <a:xfrm>
-            <a:off x="4887068" y="8786825"/>
-            <a:ext cx="9525" cy="1720412"/>
+            <a:off x="4863803" y="8822825"/>
+            <a:ext cx="9525" cy="1684412"/>
           </a:xfrm>
           <a:prstGeom prst="rect">
             <a:avLst/>
@@ -9679,8 +9749,8 @@
         </p:nvSpPr>
         <p:spPr>
           <a:xfrm>
-            <a:off x="7110731" y="184762"/>
-            <a:ext cx="9525" cy="1720412"/>
+            <a:off x="7040935" y="400762"/>
+            <a:ext cx="9525" cy="1684412"/>
           </a:xfrm>
           <a:prstGeom prst="rect">
             <a:avLst/>
@@ -9723,8 +9793,8 @@
         </p:nvSpPr>
         <p:spPr>
           <a:xfrm>
-            <a:off x="7110731" y="1905175"/>
-            <a:ext cx="9525" cy="1720412"/>
+            <a:off x="7040935" y="2085175"/>
+            <a:ext cx="9525" cy="1684412"/>
           </a:xfrm>
           <a:prstGeom prst="rect">
             <a:avLst/>
@@ -9767,8 +9837,8 @@
         </p:nvSpPr>
         <p:spPr>
           <a:xfrm>
-            <a:off x="7110731" y="3625587"/>
-            <a:ext cx="9525" cy="1720412"/>
+            <a:off x="7040935" y="3769587"/>
+            <a:ext cx="9525" cy="1684412"/>
           </a:xfrm>
           <a:prstGeom prst="rect">
             <a:avLst/>
@@ -9811,8 +9881,8 @@
         </p:nvSpPr>
         <p:spPr>
           <a:xfrm>
-            <a:off x="7110731" y="5346000"/>
-            <a:ext cx="9525" cy="1720412"/>
+            <a:off x="7040935" y="5454000"/>
+            <a:ext cx="9525" cy="1684412"/>
           </a:xfrm>
           <a:prstGeom prst="rect">
             <a:avLst/>
@@ -9855,8 +9925,8 @@
         </p:nvSpPr>
         <p:spPr>
           <a:xfrm>
-            <a:off x="7110731" y="7066412"/>
-            <a:ext cx="9525" cy="1720412"/>
+            <a:off x="7040935" y="7138412"/>
+            <a:ext cx="9525" cy="1684412"/>
           </a:xfrm>
           <a:prstGeom prst="rect">
             <a:avLst/>
@@ -9899,8 +9969,8 @@
         </p:nvSpPr>
         <p:spPr>
           <a:xfrm>
-            <a:off x="7110731" y="8786825"/>
-            <a:ext cx="9525" cy="1720412"/>
+            <a:off x="7040935" y="8822825"/>
+            <a:ext cx="9525" cy="1684412"/>
           </a:xfrm>
           <a:prstGeom prst="rect">
             <a:avLst/>
@@ -9932,6 +10002,41 @@
           <a:lstStyle/>
           <a:p>
             <a:pPr algn="ctr"/>
+          </a:p>
+        </p:txBody>
+      </p:sp>
+      <p:sp>
+        <p:nvSpPr>
+          <p:cNvPr id="65" name="TextBox 64"/>
+          <p:cNvSpPr txBox="1"/>
+          <p:nvPr/>
+        </p:nvSpPr>
+        <p:spPr>
+          <a:xfrm>
+            <a:off x="184762" y="184762"/>
+            <a:ext cx="7190475" cy="198000"/>
+          </a:xfrm>
+          <a:prstGeom prst="rect">
+            <a:avLst/>
+          </a:prstGeom>
+          <a:noFill/>
+        </p:spPr>
+        <p:txBody>
+          <a:bodyPr wrap="none" lIns="0" rIns="0" tIns="0" bIns="0">
+            <a:spAutoFit/>
+          </a:bodyPr>
+          <a:lstStyle/>
+          <a:p>
+            <a:pPr algn="l"/>
+            <a:r>
+              <a:rPr sz="900" b="0">
+                <a:solidFill>
+                  <a:srgbClr val="555555"/>
+                </a:solidFill>
+                <a:latin typeface="Arial"/>
+              </a:rPr>
+              <a:t>Карты букв · ЛИЦО</a:t>
+            </a:r>
           </a:p>
         </p:txBody>
       </p:sp>
@@ -9961,8 +10066,8 @@
         </p:nvSpPr>
         <p:spPr>
           <a:xfrm>
-            <a:off x="4891831" y="184762"/>
-            <a:ext cx="2223662" cy="1720412"/>
+            <a:off x="4868565" y="400762"/>
+            <a:ext cx="2177131" cy="1684412"/>
           </a:xfrm>
           <a:prstGeom prst="rect">
             <a:avLst/>
@@ -10003,8 +10108,8 @@
         </p:nvSpPr>
         <p:spPr>
           <a:xfrm>
-            <a:off x="2668168" y="184762"/>
-            <a:ext cx="2223662" cy="1720412"/>
+            <a:off x="2691434" y="400762"/>
+            <a:ext cx="2177131" cy="1684412"/>
           </a:xfrm>
           <a:prstGeom prst="rect">
             <a:avLst/>
@@ -10045,8 +10150,8 @@
         </p:nvSpPr>
         <p:spPr>
           <a:xfrm>
-            <a:off x="444506" y="184762"/>
-            <a:ext cx="2223662" cy="1720412"/>
+            <a:off x="514302" y="400762"/>
+            <a:ext cx="2177131" cy="1684412"/>
           </a:xfrm>
           <a:prstGeom prst="rect">
             <a:avLst/>
@@ -10087,8 +10192,8 @@
         </p:nvSpPr>
         <p:spPr>
           <a:xfrm>
-            <a:off x="4891831" y="1905175"/>
-            <a:ext cx="2223662" cy="1720412"/>
+            <a:off x="4868565" y="2085175"/>
+            <a:ext cx="2177131" cy="1684412"/>
           </a:xfrm>
           <a:prstGeom prst="rect">
             <a:avLst/>
@@ -10129,8 +10234,8 @@
         </p:nvSpPr>
         <p:spPr>
           <a:xfrm>
-            <a:off x="2668168" y="1905175"/>
-            <a:ext cx="2223662" cy="1720412"/>
+            <a:off x="2691434" y="2085175"/>
+            <a:ext cx="2177131" cy="1684412"/>
           </a:xfrm>
           <a:prstGeom prst="rect">
             <a:avLst/>
@@ -10171,8 +10276,8 @@
         </p:nvSpPr>
         <p:spPr>
           <a:xfrm>
-            <a:off x="444506" y="1905175"/>
-            <a:ext cx="2223662" cy="1720412"/>
+            <a:off x="514302" y="2085175"/>
+            <a:ext cx="2177131" cy="1684412"/>
           </a:xfrm>
           <a:prstGeom prst="rect">
             <a:avLst/>
@@ -10213,8 +10318,8 @@
         </p:nvSpPr>
         <p:spPr>
           <a:xfrm>
-            <a:off x="4891831" y="3625587"/>
-            <a:ext cx="2223662" cy="1720412"/>
+            <a:off x="4868565" y="3769587"/>
+            <a:ext cx="2177131" cy="1684412"/>
           </a:xfrm>
           <a:prstGeom prst="rect">
             <a:avLst/>
@@ -10255,8 +10360,8 @@
         </p:nvSpPr>
         <p:spPr>
           <a:xfrm>
-            <a:off x="2668168" y="3625587"/>
-            <a:ext cx="2223662" cy="1720412"/>
+            <a:off x="2691434" y="3769587"/>
+            <a:ext cx="2177131" cy="1684412"/>
           </a:xfrm>
           <a:prstGeom prst="rect">
             <a:avLst/>
@@ -10297,8 +10402,8 @@
         </p:nvSpPr>
         <p:spPr>
           <a:xfrm>
-            <a:off x="444506" y="3625587"/>
-            <a:ext cx="2223662" cy="1720412"/>
+            <a:off x="514302" y="3769587"/>
+            <a:ext cx="2177131" cy="1684412"/>
           </a:xfrm>
           <a:prstGeom prst="rect">
             <a:avLst/>
@@ -10339,8 +10444,8 @@
         </p:nvSpPr>
         <p:spPr>
           <a:xfrm>
-            <a:off x="4891831" y="5346000"/>
-            <a:ext cx="2223662" cy="1720412"/>
+            <a:off x="4868565" y="5454000"/>
+            <a:ext cx="2177131" cy="1684412"/>
           </a:xfrm>
           <a:prstGeom prst="rect">
             <a:avLst/>
@@ -10381,8 +10486,8 @@
         </p:nvSpPr>
         <p:spPr>
           <a:xfrm>
-            <a:off x="2668168" y="5346000"/>
-            <a:ext cx="2223662" cy="1720412"/>
+            <a:off x="2691434" y="5454000"/>
+            <a:ext cx="2177131" cy="1684412"/>
           </a:xfrm>
           <a:prstGeom prst="rect">
             <a:avLst/>
@@ -10423,8 +10528,8 @@
         </p:nvSpPr>
         <p:spPr>
           <a:xfrm>
-            <a:off x="444506" y="5346000"/>
-            <a:ext cx="2223662" cy="1720412"/>
+            <a:off x="514302" y="5454000"/>
+            <a:ext cx="2177131" cy="1684412"/>
           </a:xfrm>
           <a:prstGeom prst="rect">
             <a:avLst/>
@@ -10465,8 +10570,8 @@
         </p:nvSpPr>
         <p:spPr>
           <a:xfrm>
-            <a:off x="4891831" y="7066412"/>
-            <a:ext cx="2223662" cy="1720412"/>
+            <a:off x="4868565" y="7138412"/>
+            <a:ext cx="2177131" cy="1684412"/>
           </a:xfrm>
           <a:prstGeom prst="rect">
             <a:avLst/>
@@ -10507,8 +10612,8 @@
         </p:nvSpPr>
         <p:spPr>
           <a:xfrm>
-            <a:off x="2668168" y="7066412"/>
-            <a:ext cx="2223662" cy="1720412"/>
+            <a:off x="2691434" y="7138412"/>
+            <a:ext cx="2177131" cy="1684412"/>
           </a:xfrm>
           <a:prstGeom prst="rect">
             <a:avLst/>
@@ -10549,8 +10654,8 @@
         </p:nvSpPr>
         <p:spPr>
           <a:xfrm>
-            <a:off x="444506" y="7066412"/>
-            <a:ext cx="2223662" cy="1720412"/>
+            <a:off x="514302" y="7138412"/>
+            <a:ext cx="2177131" cy="1684412"/>
           </a:xfrm>
           <a:prstGeom prst="rect">
             <a:avLst/>
@@ -10591,8 +10696,8 @@
         </p:nvSpPr>
         <p:spPr>
           <a:xfrm>
-            <a:off x="4891831" y="8786825"/>
-            <a:ext cx="2223662" cy="1720412"/>
+            <a:off x="4868565" y="8822825"/>
+            <a:ext cx="2177131" cy="1684412"/>
           </a:xfrm>
           <a:prstGeom prst="rect">
             <a:avLst/>
@@ -10633,8 +10738,8 @@
         </p:nvSpPr>
         <p:spPr>
           <a:xfrm>
-            <a:off x="2668168" y="8786825"/>
-            <a:ext cx="2223662" cy="1720412"/>
+            <a:off x="2691434" y="8822825"/>
+            <a:ext cx="2177131" cy="1684412"/>
           </a:xfrm>
           <a:prstGeom prst="rect">
             <a:avLst/>
@@ -10675,8 +10780,8 @@
         </p:nvSpPr>
         <p:spPr>
           <a:xfrm>
-            <a:off x="444506" y="8786825"/>
-            <a:ext cx="2223662" cy="1720412"/>
+            <a:off x="514302" y="8822825"/>
+            <a:ext cx="2177131" cy="1684412"/>
           </a:xfrm>
           <a:prstGeom prst="rect">
             <a:avLst/>
@@ -10706,6 +10811,41 @@
           <a:lstStyle/>
           <a:p>
             <a:pPr algn="ctr"/>
+          </a:p>
+        </p:txBody>
+      </p:sp>
+      <p:sp>
+        <p:nvSpPr>
+          <p:cNvPr id="20" name="TextBox 19"/>
+          <p:cNvSpPr txBox="1"/>
+          <p:nvPr/>
+        </p:nvSpPr>
+        <p:spPr>
+          <a:xfrm>
+            <a:off x="184762" y="184762"/>
+            <a:ext cx="7190475" cy="198000"/>
+          </a:xfrm>
+          <a:prstGeom prst="rect">
+            <a:avLst/>
+          </a:prstGeom>
+          <a:noFill/>
+        </p:spPr>
+        <p:txBody>
+          <a:bodyPr wrap="none" lIns="0" rIns="0" tIns="0" bIns="0">
+            <a:spAutoFit/>
+          </a:bodyPr>
+          <a:lstStyle/>
+          <a:p>
+            <a:pPr algn="l"/>
+            <a:r>
+              <a:rPr sz="900" b="0">
+                <a:solidFill>
+                  <a:srgbClr val="555555"/>
+                </a:solidFill>
+                <a:latin typeface="Arial"/>
+              </a:rPr>
+              <a:t>Карты букв · ОБОРОТ</a:t>
+            </a:r>
           </a:p>
         </p:txBody>
       </p:sp>
@@ -10735,8 +10875,8 @@
         </p:nvSpPr>
         <p:spPr>
           <a:xfrm>
-            <a:off x="444506" y="184762"/>
-            <a:ext cx="2223662" cy="1720412"/>
+            <a:off x="514302" y="400762"/>
+            <a:ext cx="2177131" cy="1684412"/>
           </a:xfrm>
           <a:prstGeom prst="rect">
             <a:avLst/>
@@ -10762,7 +10902,7 @@
           </a:fontRef>
         </p:style>
         <p:txBody>
-          <a:bodyPr rtlCol="0" anchor="ctr" wrap="none" lIns="58517" rIns="58517" tIns="39011" bIns="39011"/>
+          <a:bodyPr rtlCol="0" anchor="ctr" wrap="none" lIns="57292" rIns="57292" tIns="38195" bIns="38195"/>
           <a:lstStyle/>
           <a:p>
             <a:pPr algn="ctr">
@@ -10793,8 +10933,8 @@
         </p:nvSpPr>
         <p:spPr>
           <a:xfrm>
-            <a:off x="2668168" y="184762"/>
-            <a:ext cx="2223662" cy="1720412"/>
+            <a:off x="2691434" y="400762"/>
+            <a:ext cx="2177131" cy="1684412"/>
           </a:xfrm>
           <a:prstGeom prst="rect">
             <a:avLst/>
@@ -10820,7 +10960,7 @@
           </a:fontRef>
         </p:style>
         <p:txBody>
-          <a:bodyPr rtlCol="0" anchor="ctr" wrap="none" lIns="58517" rIns="58517" tIns="39011" bIns="39011"/>
+          <a:bodyPr rtlCol="0" anchor="ctr" wrap="none" lIns="57292" rIns="57292" tIns="38195" bIns="38195"/>
           <a:lstStyle/>
           <a:p>
             <a:pPr algn="ctr">
@@ -10851,8 +10991,8 @@
         </p:nvSpPr>
         <p:spPr>
           <a:xfrm>
-            <a:off x="4891831" y="184762"/>
-            <a:ext cx="2223662" cy="1720412"/>
+            <a:off x="4868565" y="400762"/>
+            <a:ext cx="2177131" cy="1684412"/>
           </a:xfrm>
           <a:prstGeom prst="rect">
             <a:avLst/>
@@ -10878,7 +11018,7 @@
           </a:fontRef>
         </p:style>
         <p:txBody>
-          <a:bodyPr rtlCol="0" anchor="ctr" wrap="none" lIns="58517" rIns="58517" tIns="39011" bIns="39011"/>
+          <a:bodyPr rtlCol="0" anchor="ctr" wrap="none" lIns="57292" rIns="57292" tIns="38195" bIns="38195"/>
           <a:lstStyle/>
           <a:p>
             <a:pPr algn="ctr">
@@ -10909,8 +11049,8 @@
         </p:nvSpPr>
         <p:spPr>
           <a:xfrm>
-            <a:off x="444506" y="1905175"/>
-            <a:ext cx="2223662" cy="1720412"/>
+            <a:off x="514302" y="2085175"/>
+            <a:ext cx="2177131" cy="1684412"/>
           </a:xfrm>
           <a:prstGeom prst="rect">
             <a:avLst/>
@@ -10936,7 +11076,7 @@
           </a:fontRef>
         </p:style>
         <p:txBody>
-          <a:bodyPr rtlCol="0" anchor="ctr" wrap="none" lIns="58517" rIns="58517" tIns="39011" bIns="39011"/>
+          <a:bodyPr rtlCol="0" anchor="ctr" wrap="none" lIns="57292" rIns="57292" tIns="38195" bIns="38195"/>
           <a:lstStyle/>
           <a:p>
             <a:pPr algn="ctr">
@@ -10967,8 +11107,8 @@
         </p:nvSpPr>
         <p:spPr>
           <a:xfrm>
-            <a:off x="2668168" y="1905175"/>
-            <a:ext cx="2223662" cy="1720412"/>
+            <a:off x="2691434" y="2085175"/>
+            <a:ext cx="2177131" cy="1684412"/>
           </a:xfrm>
           <a:prstGeom prst="rect">
             <a:avLst/>
@@ -10994,7 +11134,7 @@
           </a:fontRef>
         </p:style>
         <p:txBody>
-          <a:bodyPr rtlCol="0" anchor="ctr" wrap="none" lIns="58517" rIns="58517" tIns="39011" bIns="39011"/>
+          <a:bodyPr rtlCol="0" anchor="ctr" wrap="none" lIns="57292" rIns="57292" tIns="38195" bIns="38195"/>
           <a:lstStyle/>
           <a:p>
             <a:pPr algn="ctr">
@@ -11025,8 +11165,8 @@
         </p:nvSpPr>
         <p:spPr>
           <a:xfrm>
-            <a:off x="4891831" y="1905175"/>
-            <a:ext cx="2223662" cy="1720412"/>
+            <a:off x="4868565" y="2085175"/>
+            <a:ext cx="2177131" cy="1684412"/>
           </a:xfrm>
           <a:prstGeom prst="rect">
             <a:avLst/>
@@ -11052,7 +11192,7 @@
           </a:fontRef>
         </p:style>
         <p:txBody>
-          <a:bodyPr rtlCol="0" anchor="ctr" wrap="none" lIns="58517" rIns="58517" tIns="39011" bIns="39011"/>
+          <a:bodyPr rtlCol="0" anchor="ctr" wrap="none" lIns="57292" rIns="57292" tIns="38195" bIns="38195"/>
           <a:lstStyle/>
           <a:p>
             <a:pPr algn="ctr">
@@ -11083,8 +11223,8 @@
         </p:nvSpPr>
         <p:spPr>
           <a:xfrm>
-            <a:off x="444506" y="3625587"/>
-            <a:ext cx="2223662" cy="1720412"/>
+            <a:off x="514302" y="3769587"/>
+            <a:ext cx="2177131" cy="1684412"/>
           </a:xfrm>
           <a:prstGeom prst="rect">
             <a:avLst/>
@@ -11110,7 +11250,7 @@
           </a:fontRef>
         </p:style>
         <p:txBody>
-          <a:bodyPr rtlCol="0" anchor="ctr" wrap="none" lIns="58517" rIns="58517" tIns="39011" bIns="39011"/>
+          <a:bodyPr rtlCol="0" anchor="ctr" wrap="none" lIns="57292" rIns="57292" tIns="38195" bIns="38195"/>
           <a:lstStyle/>
           <a:p>
             <a:pPr algn="ctr">
@@ -11141,8 +11281,8 @@
         </p:nvSpPr>
         <p:spPr>
           <a:xfrm>
-            <a:off x="2668168" y="3625587"/>
-            <a:ext cx="2223662" cy="1720412"/>
+            <a:off x="2691434" y="3769587"/>
+            <a:ext cx="2177131" cy="1684412"/>
           </a:xfrm>
           <a:prstGeom prst="rect">
             <a:avLst/>
@@ -11168,7 +11308,7 @@
           </a:fontRef>
         </p:style>
         <p:txBody>
-          <a:bodyPr rtlCol="0" anchor="ctr" wrap="none" lIns="58517" rIns="58517" tIns="39011" bIns="39011"/>
+          <a:bodyPr rtlCol="0" anchor="ctr" wrap="none" lIns="57292" rIns="57292" tIns="38195" bIns="38195"/>
           <a:lstStyle/>
           <a:p>
             <a:pPr algn="ctr">
@@ -11199,8 +11339,8 @@
         </p:nvSpPr>
         <p:spPr>
           <a:xfrm>
-            <a:off x="4891831" y="3625587"/>
-            <a:ext cx="2223662" cy="1720412"/>
+            <a:off x="4868565" y="3769587"/>
+            <a:ext cx="2177131" cy="1684412"/>
           </a:xfrm>
           <a:prstGeom prst="rect">
             <a:avLst/>
@@ -11226,7 +11366,7 @@
           </a:fontRef>
         </p:style>
         <p:txBody>
-          <a:bodyPr rtlCol="0" anchor="ctr" wrap="none" lIns="58517" rIns="58517" tIns="39011" bIns="39011"/>
+          <a:bodyPr rtlCol="0" anchor="ctr" wrap="none" lIns="57292" rIns="57292" tIns="38195" bIns="38195"/>
           <a:lstStyle/>
           <a:p>
             <a:pPr algn="ctr">
@@ -11257,8 +11397,8 @@
         </p:nvSpPr>
         <p:spPr>
           <a:xfrm>
-            <a:off x="444506" y="5346000"/>
-            <a:ext cx="2223662" cy="1720412"/>
+            <a:off x="514302" y="5454000"/>
+            <a:ext cx="2177131" cy="1684412"/>
           </a:xfrm>
           <a:prstGeom prst="rect">
             <a:avLst/>
@@ -11284,7 +11424,7 @@
           </a:fontRef>
         </p:style>
         <p:txBody>
-          <a:bodyPr rtlCol="0" anchor="ctr" wrap="none" lIns="58517" rIns="58517" tIns="39011" bIns="39011"/>
+          <a:bodyPr rtlCol="0" anchor="ctr" wrap="none" lIns="57292" rIns="57292" tIns="38195" bIns="38195"/>
           <a:lstStyle/>
           <a:p>
             <a:pPr algn="ctr">
@@ -11315,8 +11455,8 @@
         </p:nvSpPr>
         <p:spPr>
           <a:xfrm>
-            <a:off x="2668168" y="5346000"/>
-            <a:ext cx="2223662" cy="1720412"/>
+            <a:off x="2691434" y="5454000"/>
+            <a:ext cx="2177131" cy="1684412"/>
           </a:xfrm>
           <a:prstGeom prst="rect">
             <a:avLst/>
@@ -11342,7 +11482,7 @@
           </a:fontRef>
         </p:style>
         <p:txBody>
-          <a:bodyPr rtlCol="0" anchor="ctr" wrap="none" lIns="58517" rIns="58517" tIns="39011" bIns="39011"/>
+          <a:bodyPr rtlCol="0" anchor="ctr" wrap="none" lIns="57292" rIns="57292" tIns="38195" bIns="38195"/>
           <a:lstStyle/>
           <a:p>
             <a:pPr algn="ctr">
@@ -11373,8 +11513,8 @@
         </p:nvSpPr>
         <p:spPr>
           <a:xfrm>
-            <a:off x="4891831" y="5346000"/>
-            <a:ext cx="2223662" cy="1720412"/>
+            <a:off x="4868565" y="5454000"/>
+            <a:ext cx="2177131" cy="1684412"/>
           </a:xfrm>
           <a:prstGeom prst="rect">
             <a:avLst/>
@@ -11400,7 +11540,7 @@
           </a:fontRef>
         </p:style>
         <p:txBody>
-          <a:bodyPr rtlCol="0" anchor="ctr" wrap="none" lIns="58517" rIns="58517" tIns="39011" bIns="39011"/>
+          <a:bodyPr rtlCol="0" anchor="ctr" wrap="none" lIns="57292" rIns="57292" tIns="38195" bIns="38195"/>
           <a:lstStyle/>
           <a:p>
             <a:pPr algn="ctr">
@@ -11431,8 +11571,8 @@
         </p:nvSpPr>
         <p:spPr>
           <a:xfrm>
-            <a:off x="444506" y="7066412"/>
-            <a:ext cx="2223662" cy="1720412"/>
+            <a:off x="514302" y="7138412"/>
+            <a:ext cx="2177131" cy="1684412"/>
           </a:xfrm>
           <a:prstGeom prst="rect">
             <a:avLst/>
@@ -11458,7 +11598,7 @@
           </a:fontRef>
         </p:style>
         <p:txBody>
-          <a:bodyPr rtlCol="0" anchor="ctr" wrap="none" lIns="58517" rIns="58517" tIns="39011" bIns="39011"/>
+          <a:bodyPr rtlCol="0" anchor="ctr" wrap="none" lIns="57292" rIns="57292" tIns="38195" bIns="38195"/>
           <a:lstStyle/>
           <a:p>
             <a:pPr algn="ctr">
@@ -11489,8 +11629,8 @@
         </p:nvSpPr>
         <p:spPr>
           <a:xfrm>
-            <a:off x="2668168" y="7066412"/>
-            <a:ext cx="2223662" cy="1720412"/>
+            <a:off x="2691434" y="7138412"/>
+            <a:ext cx="2177131" cy="1684412"/>
           </a:xfrm>
           <a:prstGeom prst="rect">
             <a:avLst/>
@@ -11516,7 +11656,7 @@
           </a:fontRef>
         </p:style>
         <p:txBody>
-          <a:bodyPr rtlCol="0" anchor="ctr" wrap="none" lIns="58517" rIns="58517" tIns="39011" bIns="39011"/>
+          <a:bodyPr rtlCol="0" anchor="ctr" wrap="none" lIns="57292" rIns="57292" tIns="38195" bIns="38195"/>
           <a:lstStyle/>
           <a:p>
             <a:pPr algn="ctr">
@@ -11547,8 +11687,8 @@
         </p:nvSpPr>
         <p:spPr>
           <a:xfrm>
-            <a:off x="4891831" y="7066412"/>
-            <a:ext cx="2223662" cy="1720412"/>
+            <a:off x="4868565" y="7138412"/>
+            <a:ext cx="2177131" cy="1684412"/>
           </a:xfrm>
           <a:prstGeom prst="rect">
             <a:avLst/>
@@ -11574,7 +11714,7 @@
           </a:fontRef>
         </p:style>
         <p:txBody>
-          <a:bodyPr rtlCol="0" anchor="ctr" wrap="none" lIns="58517" rIns="58517" tIns="39011" bIns="39011"/>
+          <a:bodyPr rtlCol="0" anchor="ctr" wrap="none" lIns="57292" rIns="57292" tIns="38195" bIns="38195"/>
           <a:lstStyle/>
           <a:p>
             <a:pPr algn="ctr">
@@ -11605,8 +11745,8 @@
         </p:nvSpPr>
         <p:spPr>
           <a:xfrm>
-            <a:off x="444506" y="8786825"/>
-            <a:ext cx="2223662" cy="1720412"/>
+            <a:off x="514302" y="8822825"/>
+            <a:ext cx="2177131" cy="1684412"/>
           </a:xfrm>
           <a:prstGeom prst="rect">
             <a:avLst/>
@@ -11632,7 +11772,7 @@
           </a:fontRef>
         </p:style>
         <p:txBody>
-          <a:bodyPr rtlCol="0" anchor="ctr" wrap="none" lIns="58517" rIns="58517" tIns="39011" bIns="39011"/>
+          <a:bodyPr rtlCol="0" anchor="ctr" wrap="none" lIns="57292" rIns="57292" tIns="38195" bIns="38195"/>
           <a:lstStyle/>
           <a:p>
             <a:pPr algn="ctr">
@@ -11663,8 +11803,8 @@
         </p:nvSpPr>
         <p:spPr>
           <a:xfrm>
-            <a:off x="2668168" y="8786825"/>
-            <a:ext cx="2223662" cy="1720412"/>
+            <a:off x="2691434" y="8822825"/>
+            <a:ext cx="2177131" cy="1684412"/>
           </a:xfrm>
           <a:prstGeom prst="rect">
             <a:avLst/>
@@ -11690,7 +11830,7 @@
           </a:fontRef>
         </p:style>
         <p:txBody>
-          <a:bodyPr rtlCol="0" anchor="ctr" wrap="none" lIns="58517" rIns="58517" tIns="39011" bIns="39011"/>
+          <a:bodyPr rtlCol="0" anchor="ctr" wrap="none" lIns="57292" rIns="57292" tIns="38195" bIns="38195"/>
           <a:lstStyle/>
           <a:p>
             <a:pPr algn="ctr">
@@ -11721,8 +11861,8 @@
         </p:nvSpPr>
         <p:spPr>
           <a:xfrm>
-            <a:off x="4891831" y="8786825"/>
-            <a:ext cx="2223662" cy="1720412"/>
+            <a:off x="4868565" y="8822825"/>
+            <a:ext cx="2177131" cy="1684412"/>
           </a:xfrm>
           <a:prstGeom prst="rect">
             <a:avLst/>
@@ -11748,7 +11888,7 @@
           </a:fontRef>
         </p:style>
         <p:txBody>
-          <a:bodyPr rtlCol="0" anchor="ctr" wrap="none" lIns="58517" rIns="58517" tIns="39011" bIns="39011"/>
+          <a:bodyPr rtlCol="0" anchor="ctr" wrap="none" lIns="57292" rIns="57292" tIns="38195" bIns="38195"/>
           <a:lstStyle/>
           <a:p>
             <a:pPr algn="ctr">
@@ -11779,8 +11919,8 @@
         </p:nvSpPr>
         <p:spPr>
           <a:xfrm>
-            <a:off x="444506" y="180000"/>
-            <a:ext cx="2223662" cy="9525"/>
+            <a:off x="514302" y="396000"/>
+            <a:ext cx="2177131" cy="9525"/>
           </a:xfrm>
           <a:prstGeom prst="rect">
             <a:avLst/>
@@ -11823,8 +11963,8 @@
         </p:nvSpPr>
         <p:spPr>
           <a:xfrm>
-            <a:off x="2668168" y="180000"/>
-            <a:ext cx="2223662" cy="9525"/>
+            <a:off x="2691434" y="396000"/>
+            <a:ext cx="2177131" cy="9525"/>
           </a:xfrm>
           <a:prstGeom prst="rect">
             <a:avLst/>
@@ -11867,8 +12007,8 @@
         </p:nvSpPr>
         <p:spPr>
           <a:xfrm>
-            <a:off x="4891831" y="180000"/>
-            <a:ext cx="2223662" cy="9525"/>
+            <a:off x="4868565" y="396000"/>
+            <a:ext cx="2177131" cy="9525"/>
           </a:xfrm>
           <a:prstGeom prst="rect">
             <a:avLst/>
@@ -11911,8 +12051,8 @@
         </p:nvSpPr>
         <p:spPr>
           <a:xfrm>
-            <a:off x="444506" y="1900412"/>
-            <a:ext cx="2223662" cy="9525"/>
+            <a:off x="514302" y="2080412"/>
+            <a:ext cx="2177131" cy="9525"/>
           </a:xfrm>
           <a:prstGeom prst="rect">
             <a:avLst/>
@@ -11955,8 +12095,8 @@
         </p:nvSpPr>
         <p:spPr>
           <a:xfrm>
-            <a:off x="2668168" y="1900412"/>
-            <a:ext cx="2223662" cy="9525"/>
+            <a:off x="2691434" y="2080412"/>
+            <a:ext cx="2177131" cy="9525"/>
           </a:xfrm>
           <a:prstGeom prst="rect">
             <a:avLst/>
@@ -11999,8 +12139,8 @@
         </p:nvSpPr>
         <p:spPr>
           <a:xfrm>
-            <a:off x="4891831" y="1900412"/>
-            <a:ext cx="2223662" cy="9525"/>
+            <a:off x="4868565" y="2080412"/>
+            <a:ext cx="2177131" cy="9525"/>
           </a:xfrm>
           <a:prstGeom prst="rect">
             <a:avLst/>
@@ -12043,8 +12183,8 @@
         </p:nvSpPr>
         <p:spPr>
           <a:xfrm>
-            <a:off x="444506" y="3620825"/>
-            <a:ext cx="2223662" cy="9525"/>
+            <a:off x="514302" y="3764825"/>
+            <a:ext cx="2177131" cy="9525"/>
           </a:xfrm>
           <a:prstGeom prst="rect">
             <a:avLst/>
@@ -12087,8 +12227,8 @@
         </p:nvSpPr>
         <p:spPr>
           <a:xfrm>
-            <a:off x="2668168" y="3620825"/>
-            <a:ext cx="2223662" cy="9525"/>
+            <a:off x="2691434" y="3764825"/>
+            <a:ext cx="2177131" cy="9525"/>
           </a:xfrm>
           <a:prstGeom prst="rect">
             <a:avLst/>
@@ -12131,8 +12271,8 @@
         </p:nvSpPr>
         <p:spPr>
           <a:xfrm>
-            <a:off x="4891831" y="3620825"/>
-            <a:ext cx="2223662" cy="9525"/>
+            <a:off x="4868565" y="3764825"/>
+            <a:ext cx="2177131" cy="9525"/>
           </a:xfrm>
           <a:prstGeom prst="rect">
             <a:avLst/>
@@ -12175,8 +12315,8 @@
         </p:nvSpPr>
         <p:spPr>
           <a:xfrm>
-            <a:off x="444506" y="5341237"/>
-            <a:ext cx="2223662" cy="9525"/>
+            <a:off x="514302" y="5449237"/>
+            <a:ext cx="2177131" cy="9525"/>
           </a:xfrm>
           <a:prstGeom prst="rect">
             <a:avLst/>
@@ -12219,8 +12359,8 @@
         </p:nvSpPr>
         <p:spPr>
           <a:xfrm>
-            <a:off x="2668168" y="5341237"/>
-            <a:ext cx="2223662" cy="9525"/>
+            <a:off x="2691434" y="5449237"/>
+            <a:ext cx="2177131" cy="9525"/>
           </a:xfrm>
           <a:prstGeom prst="rect">
             <a:avLst/>
@@ -12263,8 +12403,8 @@
         </p:nvSpPr>
         <p:spPr>
           <a:xfrm>
-            <a:off x="4891831" y="5341237"/>
-            <a:ext cx="2223662" cy="9525"/>
+            <a:off x="4868565" y="5449237"/>
+            <a:ext cx="2177131" cy="9525"/>
           </a:xfrm>
           <a:prstGeom prst="rect">
             <a:avLst/>
@@ -12307,8 +12447,8 @@
         </p:nvSpPr>
         <p:spPr>
           <a:xfrm>
-            <a:off x="444506" y="7061650"/>
-            <a:ext cx="2223662" cy="9525"/>
+            <a:off x="514302" y="7133650"/>
+            <a:ext cx="2177131" cy="9525"/>
           </a:xfrm>
           <a:prstGeom prst="rect">
             <a:avLst/>
@@ -12351,8 +12491,8 @@
         </p:nvSpPr>
         <p:spPr>
           <a:xfrm>
-            <a:off x="2668168" y="7061650"/>
-            <a:ext cx="2223662" cy="9525"/>
+            <a:off x="2691434" y="7133650"/>
+            <a:ext cx="2177131" cy="9525"/>
           </a:xfrm>
           <a:prstGeom prst="rect">
             <a:avLst/>
@@ -12395,8 +12535,8 @@
         </p:nvSpPr>
         <p:spPr>
           <a:xfrm>
-            <a:off x="4891831" y="7061650"/>
-            <a:ext cx="2223662" cy="9525"/>
+            <a:off x="4868565" y="7133650"/>
+            <a:ext cx="2177131" cy="9525"/>
           </a:xfrm>
           <a:prstGeom prst="rect">
             <a:avLst/>
@@ -12439,8 +12579,8 @@
         </p:nvSpPr>
         <p:spPr>
           <a:xfrm>
-            <a:off x="444506" y="8782062"/>
-            <a:ext cx="2223662" cy="9525"/>
+            <a:off x="514302" y="8818062"/>
+            <a:ext cx="2177131" cy="9525"/>
           </a:xfrm>
           <a:prstGeom prst="rect">
             <a:avLst/>
@@ -12483,8 +12623,8 @@
         </p:nvSpPr>
         <p:spPr>
           <a:xfrm>
-            <a:off x="2668168" y="8782062"/>
-            <a:ext cx="2223662" cy="9525"/>
+            <a:off x="2691434" y="8818062"/>
+            <a:ext cx="2177131" cy="9525"/>
           </a:xfrm>
           <a:prstGeom prst="rect">
             <a:avLst/>
@@ -12527,8 +12667,8 @@
         </p:nvSpPr>
         <p:spPr>
           <a:xfrm>
-            <a:off x="4891831" y="8782062"/>
-            <a:ext cx="2223662" cy="9525"/>
+            <a:off x="4868565" y="8818062"/>
+            <a:ext cx="2177131" cy="9525"/>
           </a:xfrm>
           <a:prstGeom prst="rect">
             <a:avLst/>
@@ -12571,8 +12711,8 @@
         </p:nvSpPr>
         <p:spPr>
           <a:xfrm>
-            <a:off x="444506" y="10502475"/>
-            <a:ext cx="2223662" cy="9525"/>
+            <a:off x="514302" y="10502475"/>
+            <a:ext cx="2177131" cy="9525"/>
           </a:xfrm>
           <a:prstGeom prst="rect">
             <a:avLst/>
@@ -12615,8 +12755,8 @@
         </p:nvSpPr>
         <p:spPr>
           <a:xfrm>
-            <a:off x="2668168" y="10502475"/>
-            <a:ext cx="2223662" cy="9525"/>
+            <a:off x="2691434" y="10502475"/>
+            <a:ext cx="2177131" cy="9525"/>
           </a:xfrm>
           <a:prstGeom prst="rect">
             <a:avLst/>
@@ -12659,8 +12799,8 @@
         </p:nvSpPr>
         <p:spPr>
           <a:xfrm>
-            <a:off x="4891831" y="10502475"/>
-            <a:ext cx="2223662" cy="9525"/>
+            <a:off x="4868565" y="10502475"/>
+            <a:ext cx="2177131" cy="9525"/>
           </a:xfrm>
           <a:prstGeom prst="rect">
             <a:avLst/>
@@ -12703,8 +12843,8 @@
         </p:nvSpPr>
         <p:spPr>
           <a:xfrm>
-            <a:off x="439743" y="184762"/>
-            <a:ext cx="9525" cy="1720412"/>
+            <a:off x="509539" y="400762"/>
+            <a:ext cx="9525" cy="1684412"/>
           </a:xfrm>
           <a:prstGeom prst="rect">
             <a:avLst/>
@@ -12747,8 +12887,8 @@
         </p:nvSpPr>
         <p:spPr>
           <a:xfrm>
-            <a:off x="439743" y="1905175"/>
-            <a:ext cx="9525" cy="1720412"/>
+            <a:off x="509539" y="2085175"/>
+            <a:ext cx="9525" cy="1684412"/>
           </a:xfrm>
           <a:prstGeom prst="rect">
             <a:avLst/>
@@ -12791,8 +12931,8 @@
         </p:nvSpPr>
         <p:spPr>
           <a:xfrm>
-            <a:off x="439743" y="3625587"/>
-            <a:ext cx="9525" cy="1720412"/>
+            <a:off x="509539" y="3769587"/>
+            <a:ext cx="9525" cy="1684412"/>
           </a:xfrm>
           <a:prstGeom prst="rect">
             <a:avLst/>
@@ -12835,8 +12975,8 @@
         </p:nvSpPr>
         <p:spPr>
           <a:xfrm>
-            <a:off x="439743" y="5346000"/>
-            <a:ext cx="9525" cy="1720412"/>
+            <a:off x="509539" y="5454000"/>
+            <a:ext cx="9525" cy="1684412"/>
           </a:xfrm>
           <a:prstGeom prst="rect">
             <a:avLst/>
@@ -12879,8 +13019,8 @@
         </p:nvSpPr>
         <p:spPr>
           <a:xfrm>
-            <a:off x="439743" y="7066412"/>
-            <a:ext cx="9525" cy="1720412"/>
+            <a:off x="509539" y="7138412"/>
+            <a:ext cx="9525" cy="1684412"/>
           </a:xfrm>
           <a:prstGeom prst="rect">
             <a:avLst/>
@@ -12923,8 +13063,8 @@
         </p:nvSpPr>
         <p:spPr>
           <a:xfrm>
-            <a:off x="439743" y="8786825"/>
-            <a:ext cx="9525" cy="1720412"/>
+            <a:off x="509539" y="8822825"/>
+            <a:ext cx="9525" cy="1684412"/>
           </a:xfrm>
           <a:prstGeom prst="rect">
             <a:avLst/>
@@ -12967,8 +13107,8 @@
         </p:nvSpPr>
         <p:spPr>
           <a:xfrm>
-            <a:off x="2663406" y="184762"/>
-            <a:ext cx="9525" cy="1720412"/>
+            <a:off x="2686671" y="400762"/>
+            <a:ext cx="9525" cy="1684412"/>
           </a:xfrm>
           <a:prstGeom prst="rect">
             <a:avLst/>
@@ -13011,8 +13151,8 @@
         </p:nvSpPr>
         <p:spPr>
           <a:xfrm>
-            <a:off x="2663406" y="1905175"/>
-            <a:ext cx="9525" cy="1720412"/>
+            <a:off x="2686671" y="2085175"/>
+            <a:ext cx="9525" cy="1684412"/>
           </a:xfrm>
           <a:prstGeom prst="rect">
             <a:avLst/>
@@ -13055,8 +13195,8 @@
         </p:nvSpPr>
         <p:spPr>
           <a:xfrm>
-            <a:off x="2663406" y="3625587"/>
-            <a:ext cx="9525" cy="1720412"/>
+            <a:off x="2686671" y="3769587"/>
+            <a:ext cx="9525" cy="1684412"/>
           </a:xfrm>
           <a:prstGeom prst="rect">
             <a:avLst/>
@@ -13099,8 +13239,8 @@
         </p:nvSpPr>
         <p:spPr>
           <a:xfrm>
-            <a:off x="2663406" y="5346000"/>
-            <a:ext cx="9525" cy="1720412"/>
+            <a:off x="2686671" y="5454000"/>
+            <a:ext cx="9525" cy="1684412"/>
           </a:xfrm>
           <a:prstGeom prst="rect">
             <a:avLst/>
@@ -13143,8 +13283,8 @@
         </p:nvSpPr>
         <p:spPr>
           <a:xfrm>
-            <a:off x="2663406" y="7066412"/>
-            <a:ext cx="9525" cy="1720412"/>
+            <a:off x="2686671" y="7138412"/>
+            <a:ext cx="9525" cy="1684412"/>
           </a:xfrm>
           <a:prstGeom prst="rect">
             <a:avLst/>
@@ -13187,8 +13327,8 @@
         </p:nvSpPr>
         <p:spPr>
           <a:xfrm>
-            <a:off x="2663406" y="8786825"/>
-            <a:ext cx="9525" cy="1720412"/>
+            <a:off x="2686671" y="8822825"/>
+            <a:ext cx="9525" cy="1684412"/>
           </a:xfrm>
           <a:prstGeom prst="rect">
             <a:avLst/>
@@ -13231,8 +13371,8 @@
         </p:nvSpPr>
         <p:spPr>
           <a:xfrm>
-            <a:off x="4887068" y="184762"/>
-            <a:ext cx="9525" cy="1720412"/>
+            <a:off x="4863803" y="400762"/>
+            <a:ext cx="9525" cy="1684412"/>
           </a:xfrm>
           <a:prstGeom prst="rect">
             <a:avLst/>
@@ -13275,8 +13415,8 @@
         </p:nvSpPr>
         <p:spPr>
           <a:xfrm>
-            <a:off x="4887068" y="1905175"/>
-            <a:ext cx="9525" cy="1720412"/>
+            <a:off x="4863803" y="2085175"/>
+            <a:ext cx="9525" cy="1684412"/>
           </a:xfrm>
           <a:prstGeom prst="rect">
             <a:avLst/>
@@ -13319,8 +13459,8 @@
         </p:nvSpPr>
         <p:spPr>
           <a:xfrm>
-            <a:off x="4887068" y="3625587"/>
-            <a:ext cx="9525" cy="1720412"/>
+            <a:off x="4863803" y="3769587"/>
+            <a:ext cx="9525" cy="1684412"/>
           </a:xfrm>
           <a:prstGeom prst="rect">
             <a:avLst/>
@@ -13363,8 +13503,8 @@
         </p:nvSpPr>
         <p:spPr>
           <a:xfrm>
-            <a:off x="4887068" y="5346000"/>
-            <a:ext cx="9525" cy="1720412"/>
+            <a:off x="4863803" y="5454000"/>
+            <a:ext cx="9525" cy="1684412"/>
           </a:xfrm>
           <a:prstGeom prst="rect">
             <a:avLst/>
@@ -13407,8 +13547,8 @@
         </p:nvSpPr>
         <p:spPr>
           <a:xfrm>
-            <a:off x="4887068" y="7066412"/>
-            <a:ext cx="9525" cy="1720412"/>
+            <a:off x="4863803" y="7138412"/>
+            <a:ext cx="9525" cy="1684412"/>
           </a:xfrm>
           <a:prstGeom prst="rect">
             <a:avLst/>
@@ -13451,8 +13591,8 @@
         </p:nvSpPr>
         <p:spPr>
           <a:xfrm>
-            <a:off x="4887068" y="8786825"/>
-            <a:ext cx="9525" cy="1720412"/>
+            <a:off x="4863803" y="8822825"/>
+            <a:ext cx="9525" cy="1684412"/>
           </a:xfrm>
           <a:prstGeom prst="rect">
             <a:avLst/>
@@ -13495,8 +13635,8 @@
         </p:nvSpPr>
         <p:spPr>
           <a:xfrm>
-            <a:off x="7110731" y="184762"/>
-            <a:ext cx="9525" cy="1720412"/>
+            <a:off x="7040935" y="400762"/>
+            <a:ext cx="9525" cy="1684412"/>
           </a:xfrm>
           <a:prstGeom prst="rect">
             <a:avLst/>
@@ -13539,8 +13679,8 @@
         </p:nvSpPr>
         <p:spPr>
           <a:xfrm>
-            <a:off x="7110731" y="1905175"/>
-            <a:ext cx="9525" cy="1720412"/>
+            <a:off x="7040935" y="2085175"/>
+            <a:ext cx="9525" cy="1684412"/>
           </a:xfrm>
           <a:prstGeom prst="rect">
             <a:avLst/>
@@ -13583,8 +13723,8 @@
         </p:nvSpPr>
         <p:spPr>
           <a:xfrm>
-            <a:off x="7110731" y="3625587"/>
-            <a:ext cx="9525" cy="1720412"/>
+            <a:off x="7040935" y="3769587"/>
+            <a:ext cx="9525" cy="1684412"/>
           </a:xfrm>
           <a:prstGeom prst="rect">
             <a:avLst/>
@@ -13627,8 +13767,8 @@
         </p:nvSpPr>
         <p:spPr>
           <a:xfrm>
-            <a:off x="7110731" y="5346000"/>
-            <a:ext cx="9525" cy="1720412"/>
+            <a:off x="7040935" y="5454000"/>
+            <a:ext cx="9525" cy="1684412"/>
           </a:xfrm>
           <a:prstGeom prst="rect">
             <a:avLst/>
@@ -13671,8 +13811,8 @@
         </p:nvSpPr>
         <p:spPr>
           <a:xfrm>
-            <a:off x="7110731" y="7066412"/>
-            <a:ext cx="9525" cy="1720412"/>
+            <a:off x="7040935" y="7138412"/>
+            <a:ext cx="9525" cy="1684412"/>
           </a:xfrm>
           <a:prstGeom prst="rect">
             <a:avLst/>
@@ -13715,8 +13855,8 @@
         </p:nvSpPr>
         <p:spPr>
           <a:xfrm>
-            <a:off x="7110731" y="8786825"/>
-            <a:ext cx="9525" cy="1720412"/>
+            <a:off x="7040935" y="8822825"/>
+            <a:ext cx="9525" cy="1684412"/>
           </a:xfrm>
           <a:prstGeom prst="rect">
             <a:avLst/>
@@ -13748,6 +13888,41 @@
           <a:lstStyle/>
           <a:p>
             <a:pPr algn="ctr"/>
+          </a:p>
+        </p:txBody>
+      </p:sp>
+      <p:sp>
+        <p:nvSpPr>
+          <p:cNvPr id="65" name="TextBox 64"/>
+          <p:cNvSpPr txBox="1"/>
+          <p:nvPr/>
+        </p:nvSpPr>
+        <p:spPr>
+          <a:xfrm>
+            <a:off x="184762" y="184762"/>
+            <a:ext cx="7190475" cy="198000"/>
+          </a:xfrm>
+          <a:prstGeom prst="rect">
+            <a:avLst/>
+          </a:prstGeom>
+          <a:noFill/>
+        </p:spPr>
+        <p:txBody>
+          <a:bodyPr wrap="none" lIns="0" rIns="0" tIns="0" bIns="0">
+            <a:spAutoFit/>
+          </a:bodyPr>
+          <a:lstStyle/>
+          <a:p>
+            <a:pPr algn="l"/>
+            <a:r>
+              <a:rPr sz="900" b="0">
+                <a:solidFill>
+                  <a:srgbClr val="555555"/>
+                </a:solidFill>
+                <a:latin typeface="Arial"/>
+              </a:rPr>
+              <a:t>Карты букв · ЛИЦО</a:t>
+            </a:r>
           </a:p>
         </p:txBody>
       </p:sp>
@@ -13777,8 +13952,8 @@
         </p:nvSpPr>
         <p:spPr>
           <a:xfrm>
-            <a:off x="4891831" y="184762"/>
-            <a:ext cx="2223662" cy="1720412"/>
+            <a:off x="4868565" y="400762"/>
+            <a:ext cx="2177131" cy="1684412"/>
           </a:xfrm>
           <a:prstGeom prst="rect">
             <a:avLst/>
@@ -13819,8 +13994,8 @@
         </p:nvSpPr>
         <p:spPr>
           <a:xfrm>
-            <a:off x="2668168" y="184762"/>
-            <a:ext cx="2223662" cy="1720412"/>
+            <a:off x="2691434" y="400762"/>
+            <a:ext cx="2177131" cy="1684412"/>
           </a:xfrm>
           <a:prstGeom prst="rect">
             <a:avLst/>
@@ -13861,8 +14036,8 @@
         </p:nvSpPr>
         <p:spPr>
           <a:xfrm>
-            <a:off x="444506" y="184762"/>
-            <a:ext cx="2223662" cy="1720412"/>
+            <a:off x="514302" y="400762"/>
+            <a:ext cx="2177131" cy="1684412"/>
           </a:xfrm>
           <a:prstGeom prst="rect">
             <a:avLst/>
@@ -13903,8 +14078,8 @@
         </p:nvSpPr>
         <p:spPr>
           <a:xfrm>
-            <a:off x="4891831" y="1905175"/>
-            <a:ext cx="2223662" cy="1720412"/>
+            <a:off x="4868565" y="2085175"/>
+            <a:ext cx="2177131" cy="1684412"/>
           </a:xfrm>
           <a:prstGeom prst="rect">
             <a:avLst/>
@@ -13945,8 +14120,8 @@
         </p:nvSpPr>
         <p:spPr>
           <a:xfrm>
-            <a:off x="2668168" y="1905175"/>
-            <a:ext cx="2223662" cy="1720412"/>
+            <a:off x="2691434" y="2085175"/>
+            <a:ext cx="2177131" cy="1684412"/>
           </a:xfrm>
           <a:prstGeom prst="rect">
             <a:avLst/>
@@ -13987,8 +14162,8 @@
         </p:nvSpPr>
         <p:spPr>
           <a:xfrm>
-            <a:off x="444506" y="1905175"/>
-            <a:ext cx="2223662" cy="1720412"/>
+            <a:off x="514302" y="2085175"/>
+            <a:ext cx="2177131" cy="1684412"/>
           </a:xfrm>
           <a:prstGeom prst="rect">
             <a:avLst/>
@@ -14029,8 +14204,8 @@
         </p:nvSpPr>
         <p:spPr>
           <a:xfrm>
-            <a:off x="4891831" y="3625587"/>
-            <a:ext cx="2223662" cy="1720412"/>
+            <a:off x="4868565" y="3769587"/>
+            <a:ext cx="2177131" cy="1684412"/>
           </a:xfrm>
           <a:prstGeom prst="rect">
             <a:avLst/>
@@ -14071,8 +14246,8 @@
         </p:nvSpPr>
         <p:spPr>
           <a:xfrm>
-            <a:off x="2668168" y="3625587"/>
-            <a:ext cx="2223662" cy="1720412"/>
+            <a:off x="2691434" y="3769587"/>
+            <a:ext cx="2177131" cy="1684412"/>
           </a:xfrm>
           <a:prstGeom prst="rect">
             <a:avLst/>
@@ -14113,8 +14288,8 @@
         </p:nvSpPr>
         <p:spPr>
           <a:xfrm>
-            <a:off x="444506" y="3625587"/>
-            <a:ext cx="2223662" cy="1720412"/>
+            <a:off x="514302" y="3769587"/>
+            <a:ext cx="2177131" cy="1684412"/>
           </a:xfrm>
           <a:prstGeom prst="rect">
             <a:avLst/>
@@ -14155,8 +14330,8 @@
         </p:nvSpPr>
         <p:spPr>
           <a:xfrm>
-            <a:off x="4891831" y="5346000"/>
-            <a:ext cx="2223662" cy="1720412"/>
+            <a:off x="4868565" y="5454000"/>
+            <a:ext cx="2177131" cy="1684412"/>
           </a:xfrm>
           <a:prstGeom prst="rect">
             <a:avLst/>
@@ -14197,8 +14372,8 @@
         </p:nvSpPr>
         <p:spPr>
           <a:xfrm>
-            <a:off x="2668168" y="5346000"/>
-            <a:ext cx="2223662" cy="1720412"/>
+            <a:off x="2691434" y="5454000"/>
+            <a:ext cx="2177131" cy="1684412"/>
           </a:xfrm>
           <a:prstGeom prst="rect">
             <a:avLst/>
@@ -14239,8 +14414,8 @@
         </p:nvSpPr>
         <p:spPr>
           <a:xfrm>
-            <a:off x="444506" y="5346000"/>
-            <a:ext cx="2223662" cy="1720412"/>
+            <a:off x="514302" y="5454000"/>
+            <a:ext cx="2177131" cy="1684412"/>
           </a:xfrm>
           <a:prstGeom prst="rect">
             <a:avLst/>
@@ -14281,8 +14456,8 @@
         </p:nvSpPr>
         <p:spPr>
           <a:xfrm>
-            <a:off x="4891831" y="7066412"/>
-            <a:ext cx="2223662" cy="1720412"/>
+            <a:off x="4868565" y="7138412"/>
+            <a:ext cx="2177131" cy="1684412"/>
           </a:xfrm>
           <a:prstGeom prst="rect">
             <a:avLst/>
@@ -14323,8 +14498,8 @@
         </p:nvSpPr>
         <p:spPr>
           <a:xfrm>
-            <a:off x="2668168" y="7066412"/>
-            <a:ext cx="2223662" cy="1720412"/>
+            <a:off x="2691434" y="7138412"/>
+            <a:ext cx="2177131" cy="1684412"/>
           </a:xfrm>
           <a:prstGeom prst="rect">
             <a:avLst/>
@@ -14365,8 +14540,8 @@
         </p:nvSpPr>
         <p:spPr>
           <a:xfrm>
-            <a:off x="444506" y="7066412"/>
-            <a:ext cx="2223662" cy="1720412"/>
+            <a:off x="514302" y="7138412"/>
+            <a:ext cx="2177131" cy="1684412"/>
           </a:xfrm>
           <a:prstGeom prst="rect">
             <a:avLst/>
@@ -14407,8 +14582,8 @@
         </p:nvSpPr>
         <p:spPr>
           <a:xfrm>
-            <a:off x="4891831" y="8786825"/>
-            <a:ext cx="2223662" cy="1720412"/>
+            <a:off x="4868565" y="8822825"/>
+            <a:ext cx="2177131" cy="1684412"/>
           </a:xfrm>
           <a:prstGeom prst="rect">
             <a:avLst/>
@@ -14449,8 +14624,8 @@
         </p:nvSpPr>
         <p:spPr>
           <a:xfrm>
-            <a:off x="2668168" y="8786825"/>
-            <a:ext cx="2223662" cy="1720412"/>
+            <a:off x="2691434" y="8822825"/>
+            <a:ext cx="2177131" cy="1684412"/>
           </a:xfrm>
           <a:prstGeom prst="rect">
             <a:avLst/>
@@ -14491,8 +14666,8 @@
         </p:nvSpPr>
         <p:spPr>
           <a:xfrm>
-            <a:off x="444506" y="8786825"/>
-            <a:ext cx="2223662" cy="1720412"/>
+            <a:off x="514302" y="8822825"/>
+            <a:ext cx="2177131" cy="1684412"/>
           </a:xfrm>
           <a:prstGeom prst="rect">
             <a:avLst/>
@@ -14522,6 +14697,41 @@
           <a:lstStyle/>
           <a:p>
             <a:pPr algn="ctr"/>
+          </a:p>
+        </p:txBody>
+      </p:sp>
+      <p:sp>
+        <p:nvSpPr>
+          <p:cNvPr id="20" name="TextBox 19"/>
+          <p:cNvSpPr txBox="1"/>
+          <p:nvPr/>
+        </p:nvSpPr>
+        <p:spPr>
+          <a:xfrm>
+            <a:off x="184762" y="184762"/>
+            <a:ext cx="7190475" cy="198000"/>
+          </a:xfrm>
+          <a:prstGeom prst="rect">
+            <a:avLst/>
+          </a:prstGeom>
+          <a:noFill/>
+        </p:spPr>
+        <p:txBody>
+          <a:bodyPr wrap="none" lIns="0" rIns="0" tIns="0" bIns="0">
+            <a:spAutoFit/>
+          </a:bodyPr>
+          <a:lstStyle/>
+          <a:p>
+            <a:pPr algn="l"/>
+            <a:r>
+              <a:rPr sz="900" b="0">
+                <a:solidFill>
+                  <a:srgbClr val="555555"/>
+                </a:solidFill>
+                <a:latin typeface="Arial"/>
+              </a:rPr>
+              <a:t>Карты букв · ОБОРОТ</a:t>
+            </a:r>
           </a:p>
         </p:txBody>
       </p:sp>
@@ -14551,8 +14761,8 @@
         </p:nvSpPr>
         <p:spPr>
           <a:xfrm>
-            <a:off x="444506" y="184762"/>
-            <a:ext cx="2223662" cy="1720412"/>
+            <a:off x="514302" y="400762"/>
+            <a:ext cx="2177131" cy="1684412"/>
           </a:xfrm>
           <a:prstGeom prst="rect">
             <a:avLst/>
@@ -14578,7 +14788,7 @@
           </a:fontRef>
         </p:style>
         <p:txBody>
-          <a:bodyPr rtlCol="0" anchor="ctr" wrap="none" lIns="58517" rIns="58517" tIns="39011" bIns="39011"/>
+          <a:bodyPr rtlCol="0" anchor="ctr" wrap="none" lIns="57292" rIns="57292" tIns="38195" bIns="38195"/>
           <a:lstStyle/>
           <a:p>
             <a:pPr algn="ctr">
@@ -14609,8 +14819,8 @@
         </p:nvSpPr>
         <p:spPr>
           <a:xfrm>
-            <a:off x="2668168" y="184762"/>
-            <a:ext cx="2223662" cy="1720412"/>
+            <a:off x="2691434" y="400762"/>
+            <a:ext cx="2177131" cy="1684412"/>
           </a:xfrm>
           <a:prstGeom prst="rect">
             <a:avLst/>
@@ -14636,7 +14846,7 @@
           </a:fontRef>
         </p:style>
         <p:txBody>
-          <a:bodyPr rtlCol="0" anchor="ctr" wrap="none" lIns="58517" rIns="58517" tIns="39011" bIns="39011"/>
+          <a:bodyPr rtlCol="0" anchor="ctr" wrap="none" lIns="57292" rIns="57292" tIns="38195" bIns="38195"/>
           <a:lstStyle/>
           <a:p>
             <a:pPr algn="ctr">
@@ -14667,8 +14877,8 @@
         </p:nvSpPr>
         <p:spPr>
           <a:xfrm>
-            <a:off x="4891831" y="184762"/>
-            <a:ext cx="2223662" cy="1720412"/>
+            <a:off x="4868565" y="400762"/>
+            <a:ext cx="2177131" cy="1684412"/>
           </a:xfrm>
           <a:prstGeom prst="rect">
             <a:avLst/>
@@ -14694,7 +14904,7 @@
           </a:fontRef>
         </p:style>
         <p:txBody>
-          <a:bodyPr rtlCol="0" anchor="ctr" wrap="none" lIns="58517" rIns="58517" tIns="39011" bIns="39011"/>
+          <a:bodyPr rtlCol="0" anchor="ctr" wrap="none" lIns="57292" rIns="57292" tIns="38195" bIns="38195"/>
           <a:lstStyle/>
           <a:p>
             <a:pPr algn="ctr">
@@ -14725,8 +14935,8 @@
         </p:nvSpPr>
         <p:spPr>
           <a:xfrm>
-            <a:off x="444506" y="1905175"/>
-            <a:ext cx="2223662" cy="1720412"/>
+            <a:off x="514302" y="2085175"/>
+            <a:ext cx="2177131" cy="1684412"/>
           </a:xfrm>
           <a:prstGeom prst="rect">
             <a:avLst/>
@@ -14752,7 +14962,7 @@
           </a:fontRef>
         </p:style>
         <p:txBody>
-          <a:bodyPr rtlCol="0" anchor="ctr" wrap="none" lIns="58517" rIns="58517" tIns="39011" bIns="39011"/>
+          <a:bodyPr rtlCol="0" anchor="ctr" wrap="none" lIns="57292" rIns="57292" tIns="38195" bIns="38195"/>
           <a:lstStyle/>
           <a:p>
             <a:pPr algn="ctr">
@@ -14783,8 +14993,8 @@
         </p:nvSpPr>
         <p:spPr>
           <a:xfrm>
-            <a:off x="2668168" y="1905175"/>
-            <a:ext cx="2223662" cy="1720412"/>
+            <a:off x="2691434" y="2085175"/>
+            <a:ext cx="2177131" cy="1684412"/>
           </a:xfrm>
           <a:prstGeom prst="rect">
             <a:avLst/>
@@ -14810,7 +15020,7 @@
           </a:fontRef>
         </p:style>
         <p:txBody>
-          <a:bodyPr rtlCol="0" anchor="ctr" wrap="none" lIns="58517" rIns="58517" tIns="39011" bIns="39011"/>
+          <a:bodyPr rtlCol="0" anchor="ctr" wrap="none" lIns="57292" rIns="57292" tIns="38195" bIns="38195"/>
           <a:lstStyle/>
           <a:p>
             <a:pPr algn="ctr">
@@ -14841,8 +15051,8 @@
         </p:nvSpPr>
         <p:spPr>
           <a:xfrm>
-            <a:off x="4891831" y="1905175"/>
-            <a:ext cx="2223662" cy="1720412"/>
+            <a:off x="4868565" y="2085175"/>
+            <a:ext cx="2177131" cy="1684412"/>
           </a:xfrm>
           <a:prstGeom prst="rect">
             <a:avLst/>
@@ -14868,7 +15078,7 @@
           </a:fontRef>
         </p:style>
         <p:txBody>
-          <a:bodyPr rtlCol="0" anchor="ctr" wrap="none" lIns="58517" rIns="58517" tIns="39011" bIns="39011"/>
+          <a:bodyPr rtlCol="0" anchor="ctr" wrap="none" lIns="57292" rIns="57292" tIns="38195" bIns="38195"/>
           <a:lstStyle/>
           <a:p>
             <a:pPr algn="ctr">
@@ -14899,8 +15109,8 @@
         </p:nvSpPr>
         <p:spPr>
           <a:xfrm>
-            <a:off x="444506" y="3625587"/>
-            <a:ext cx="2223662" cy="1720412"/>
+            <a:off x="514302" y="3769587"/>
+            <a:ext cx="2177131" cy="1684412"/>
           </a:xfrm>
           <a:prstGeom prst="rect">
             <a:avLst/>
@@ -14926,7 +15136,7 @@
           </a:fontRef>
         </p:style>
         <p:txBody>
-          <a:bodyPr rtlCol="0" anchor="ctr" wrap="none" lIns="58517" rIns="58517" tIns="39011" bIns="39011"/>
+          <a:bodyPr rtlCol="0" anchor="ctr" wrap="none" lIns="57292" rIns="57292" tIns="38195" bIns="38195"/>
           <a:lstStyle/>
           <a:p>
             <a:pPr algn="ctr">
@@ -14957,8 +15167,8 @@
         </p:nvSpPr>
         <p:spPr>
           <a:xfrm>
-            <a:off x="2668168" y="3625587"/>
-            <a:ext cx="2223662" cy="1720412"/>
+            <a:off x="2691434" y="3769587"/>
+            <a:ext cx="2177131" cy="1684412"/>
           </a:xfrm>
           <a:prstGeom prst="rect">
             <a:avLst/>
@@ -14984,7 +15194,7 @@
           </a:fontRef>
         </p:style>
         <p:txBody>
-          <a:bodyPr rtlCol="0" anchor="ctr" wrap="none" lIns="58517" rIns="58517" tIns="39011" bIns="39011"/>
+          <a:bodyPr rtlCol="0" anchor="ctr" wrap="none" lIns="57292" rIns="57292" tIns="38195" bIns="38195"/>
           <a:lstStyle/>
           <a:p>
             <a:pPr algn="ctr">
@@ -15015,8 +15225,8 @@
         </p:nvSpPr>
         <p:spPr>
           <a:xfrm>
-            <a:off x="4891831" y="3625587"/>
-            <a:ext cx="2223662" cy="1720412"/>
+            <a:off x="4868565" y="3769587"/>
+            <a:ext cx="2177131" cy="1684412"/>
           </a:xfrm>
           <a:prstGeom prst="rect">
             <a:avLst/>
@@ -15042,7 +15252,7 @@
           </a:fontRef>
         </p:style>
         <p:txBody>
-          <a:bodyPr rtlCol="0" anchor="ctr" wrap="none" lIns="58517" rIns="58517" tIns="39011" bIns="39011"/>
+          <a:bodyPr rtlCol="0" anchor="ctr" wrap="none" lIns="57292" rIns="57292" tIns="38195" bIns="38195"/>
           <a:lstStyle/>
           <a:p>
             <a:pPr algn="ctr">
@@ -15073,8 +15283,8 @@
         </p:nvSpPr>
         <p:spPr>
           <a:xfrm>
-            <a:off x="444506" y="5346000"/>
-            <a:ext cx="2223662" cy="1720412"/>
+            <a:off x="514302" y="5454000"/>
+            <a:ext cx="2177131" cy="1684412"/>
           </a:xfrm>
           <a:prstGeom prst="rect">
             <a:avLst/>
@@ -15100,7 +15310,7 @@
           </a:fontRef>
         </p:style>
         <p:txBody>
-          <a:bodyPr rtlCol="0" anchor="ctr" wrap="none" lIns="58517" rIns="58517" tIns="39011" bIns="39011"/>
+          <a:bodyPr rtlCol="0" anchor="ctr" wrap="none" lIns="57292" rIns="57292" tIns="38195" bIns="38195"/>
           <a:lstStyle/>
           <a:p>
             <a:pPr algn="ctr">
@@ -15131,8 +15341,8 @@
         </p:nvSpPr>
         <p:spPr>
           <a:xfrm>
-            <a:off x="2668168" y="5346000"/>
-            <a:ext cx="2223662" cy="1720412"/>
+            <a:off x="2691434" y="5454000"/>
+            <a:ext cx="2177131" cy="1684412"/>
           </a:xfrm>
           <a:prstGeom prst="rect">
             <a:avLst/>
@@ -15158,7 +15368,7 @@
           </a:fontRef>
         </p:style>
         <p:txBody>
-          <a:bodyPr rtlCol="0" anchor="ctr" wrap="none" lIns="58517" rIns="58517" tIns="39011" bIns="39011"/>
+          <a:bodyPr rtlCol="0" anchor="ctr" wrap="none" lIns="57292" rIns="57292" tIns="38195" bIns="38195"/>
           <a:lstStyle/>
           <a:p>
             <a:pPr algn="ctr">
@@ -15189,8 +15399,8 @@
         </p:nvSpPr>
         <p:spPr>
           <a:xfrm>
-            <a:off x="4891831" y="5346000"/>
-            <a:ext cx="2223662" cy="1720412"/>
+            <a:off x="4868565" y="5454000"/>
+            <a:ext cx="2177131" cy="1684412"/>
           </a:xfrm>
           <a:prstGeom prst="rect">
             <a:avLst/>
@@ -15216,7 +15426,7 @@
           </a:fontRef>
         </p:style>
         <p:txBody>
-          <a:bodyPr rtlCol="0" anchor="ctr" wrap="none" lIns="58517" rIns="58517" tIns="39011" bIns="39011"/>
+          <a:bodyPr rtlCol="0" anchor="ctr" wrap="none" lIns="57292" rIns="57292" tIns="38195" bIns="38195"/>
           <a:lstStyle/>
           <a:p>
             <a:pPr algn="ctr">
@@ -15247,8 +15457,8 @@
         </p:nvSpPr>
         <p:spPr>
           <a:xfrm>
-            <a:off x="444506" y="7066412"/>
-            <a:ext cx="2223662" cy="1720412"/>
+            <a:off x="514302" y="7138412"/>
+            <a:ext cx="2177131" cy="1684412"/>
           </a:xfrm>
           <a:prstGeom prst="rect">
             <a:avLst/>
@@ -15274,7 +15484,7 @@
           </a:fontRef>
         </p:style>
         <p:txBody>
-          <a:bodyPr rtlCol="0" anchor="ctr" wrap="none" lIns="58517" rIns="58517" tIns="39011" bIns="39011"/>
+          <a:bodyPr rtlCol="0" anchor="ctr" wrap="none" lIns="57292" rIns="57292" tIns="38195" bIns="38195"/>
           <a:lstStyle/>
           <a:p>
             <a:pPr algn="ctr">
@@ -15305,8 +15515,8 @@
         </p:nvSpPr>
         <p:spPr>
           <a:xfrm>
-            <a:off x="2668168" y="7066412"/>
-            <a:ext cx="2223662" cy="1720412"/>
+            <a:off x="2691434" y="7138412"/>
+            <a:ext cx="2177131" cy="1684412"/>
           </a:xfrm>
           <a:prstGeom prst="rect">
             <a:avLst/>
@@ -15332,7 +15542,7 @@
           </a:fontRef>
         </p:style>
         <p:txBody>
-          <a:bodyPr rtlCol="0" anchor="ctr" wrap="none" lIns="58517" rIns="58517" tIns="39011" bIns="39011"/>
+          <a:bodyPr rtlCol="0" anchor="ctr" wrap="none" lIns="57292" rIns="57292" tIns="38195" bIns="38195"/>
           <a:lstStyle/>
           <a:p>
             <a:pPr algn="ctr">
@@ -15363,8 +15573,8 @@
         </p:nvSpPr>
         <p:spPr>
           <a:xfrm>
-            <a:off x="4891831" y="7066412"/>
-            <a:ext cx="2223662" cy="1720412"/>
+            <a:off x="4868565" y="7138412"/>
+            <a:ext cx="2177131" cy="1684412"/>
           </a:xfrm>
           <a:prstGeom prst="rect">
             <a:avLst/>
@@ -15390,7 +15600,7 @@
           </a:fontRef>
         </p:style>
         <p:txBody>
-          <a:bodyPr rtlCol="0" anchor="ctr" wrap="none" lIns="58517" rIns="58517" tIns="39011" bIns="39011"/>
+          <a:bodyPr rtlCol="0" anchor="ctr" wrap="none" lIns="57292" rIns="57292" tIns="38195" bIns="38195"/>
           <a:lstStyle/>
           <a:p>
             <a:pPr algn="ctr">
@@ -15421,8 +15631,8 @@
         </p:nvSpPr>
         <p:spPr>
           <a:xfrm>
-            <a:off x="444506" y="8786825"/>
-            <a:ext cx="2223662" cy="1720412"/>
+            <a:off x="514302" y="8822825"/>
+            <a:ext cx="2177131" cy="1684412"/>
           </a:xfrm>
           <a:prstGeom prst="rect">
             <a:avLst/>
@@ -15448,7 +15658,7 @@
           </a:fontRef>
         </p:style>
         <p:txBody>
-          <a:bodyPr rtlCol="0" anchor="ctr" wrap="none" lIns="58517" rIns="58517" tIns="39011" bIns="39011"/>
+          <a:bodyPr rtlCol="0" anchor="ctr" wrap="none" lIns="57292" rIns="57292" tIns="38195" bIns="38195"/>
           <a:lstStyle/>
           <a:p>
             <a:pPr algn="ctr">
@@ -15479,8 +15689,8 @@
         </p:nvSpPr>
         <p:spPr>
           <a:xfrm>
-            <a:off x="2668168" y="8786825"/>
-            <a:ext cx="2223662" cy="1720412"/>
+            <a:off x="2691434" y="8822825"/>
+            <a:ext cx="2177131" cy="1684412"/>
           </a:xfrm>
           <a:prstGeom prst="rect">
             <a:avLst/>
@@ -15506,7 +15716,7 @@
           </a:fontRef>
         </p:style>
         <p:txBody>
-          <a:bodyPr rtlCol="0" anchor="ctr" wrap="none" lIns="58517" rIns="58517" tIns="39011" bIns="39011"/>
+          <a:bodyPr rtlCol="0" anchor="ctr" wrap="none" lIns="57292" rIns="57292" tIns="38195" bIns="38195"/>
           <a:lstStyle/>
           <a:p>
             <a:pPr algn="ctr">
@@ -15537,8 +15747,8 @@
         </p:nvSpPr>
         <p:spPr>
           <a:xfrm>
-            <a:off x="4891831" y="8786825"/>
-            <a:ext cx="2223662" cy="1720412"/>
+            <a:off x="4868565" y="8822825"/>
+            <a:ext cx="2177131" cy="1684412"/>
           </a:xfrm>
           <a:prstGeom prst="rect">
             <a:avLst/>
@@ -15564,7 +15774,7 @@
           </a:fontRef>
         </p:style>
         <p:txBody>
-          <a:bodyPr rtlCol="0" anchor="ctr" wrap="none" lIns="58517" rIns="58517" tIns="39011" bIns="39011"/>
+          <a:bodyPr rtlCol="0" anchor="ctr" wrap="none" lIns="57292" rIns="57292" tIns="38195" bIns="38195"/>
           <a:lstStyle/>
           <a:p>
             <a:pPr algn="ctr">
@@ -15595,8 +15805,8 @@
         </p:nvSpPr>
         <p:spPr>
           <a:xfrm>
-            <a:off x="444506" y="180000"/>
-            <a:ext cx="2223662" cy="9525"/>
+            <a:off x="514302" y="396000"/>
+            <a:ext cx="2177131" cy="9525"/>
           </a:xfrm>
           <a:prstGeom prst="rect">
             <a:avLst/>
@@ -15639,8 +15849,8 @@
         </p:nvSpPr>
         <p:spPr>
           <a:xfrm>
-            <a:off x="2668168" y="180000"/>
-            <a:ext cx="2223662" cy="9525"/>
+            <a:off x="2691434" y="396000"/>
+            <a:ext cx="2177131" cy="9525"/>
           </a:xfrm>
           <a:prstGeom prst="rect">
             <a:avLst/>
@@ -15683,8 +15893,8 @@
         </p:nvSpPr>
         <p:spPr>
           <a:xfrm>
-            <a:off x="4891831" y="180000"/>
-            <a:ext cx="2223662" cy="9525"/>
+            <a:off x="4868565" y="396000"/>
+            <a:ext cx="2177131" cy="9525"/>
           </a:xfrm>
           <a:prstGeom prst="rect">
             <a:avLst/>
@@ -15727,8 +15937,8 @@
         </p:nvSpPr>
         <p:spPr>
           <a:xfrm>
-            <a:off x="444506" y="1900412"/>
-            <a:ext cx="2223662" cy="9525"/>
+            <a:off x="514302" y="2080412"/>
+            <a:ext cx="2177131" cy="9525"/>
           </a:xfrm>
           <a:prstGeom prst="rect">
             <a:avLst/>
@@ -15771,8 +15981,8 @@
         </p:nvSpPr>
         <p:spPr>
           <a:xfrm>
-            <a:off x="2668168" y="1900412"/>
-            <a:ext cx="2223662" cy="9525"/>
+            <a:off x="2691434" y="2080412"/>
+            <a:ext cx="2177131" cy="9525"/>
           </a:xfrm>
           <a:prstGeom prst="rect">
             <a:avLst/>
@@ -15815,8 +16025,8 @@
         </p:nvSpPr>
         <p:spPr>
           <a:xfrm>
-            <a:off x="4891831" y="1900412"/>
-            <a:ext cx="2223662" cy="9525"/>
+            <a:off x="4868565" y="2080412"/>
+            <a:ext cx="2177131" cy="9525"/>
           </a:xfrm>
           <a:prstGeom prst="rect">
             <a:avLst/>
@@ -15859,8 +16069,8 @@
         </p:nvSpPr>
         <p:spPr>
           <a:xfrm>
-            <a:off x="444506" y="3620825"/>
-            <a:ext cx="2223662" cy="9525"/>
+            <a:off x="514302" y="3764825"/>
+            <a:ext cx="2177131" cy="9525"/>
           </a:xfrm>
           <a:prstGeom prst="rect">
             <a:avLst/>
@@ -15903,8 +16113,8 @@
         </p:nvSpPr>
         <p:spPr>
           <a:xfrm>
-            <a:off x="2668168" y="3620825"/>
-            <a:ext cx="2223662" cy="9525"/>
+            <a:off x="2691434" y="3764825"/>
+            <a:ext cx="2177131" cy="9525"/>
           </a:xfrm>
           <a:prstGeom prst="rect">
             <a:avLst/>
@@ -15947,8 +16157,8 @@
         </p:nvSpPr>
         <p:spPr>
           <a:xfrm>
-            <a:off x="4891831" y="3620825"/>
-            <a:ext cx="2223662" cy="9525"/>
+            <a:off x="4868565" y="3764825"/>
+            <a:ext cx="2177131" cy="9525"/>
           </a:xfrm>
           <a:prstGeom prst="rect">
             <a:avLst/>
@@ -15991,8 +16201,8 @@
         </p:nvSpPr>
         <p:spPr>
           <a:xfrm>
-            <a:off x="444506" y="5341237"/>
-            <a:ext cx="2223662" cy="9525"/>
+            <a:off x="514302" y="5449237"/>
+            <a:ext cx="2177131" cy="9525"/>
           </a:xfrm>
           <a:prstGeom prst="rect">
             <a:avLst/>
@@ -16035,8 +16245,8 @@
         </p:nvSpPr>
         <p:spPr>
           <a:xfrm>
-            <a:off x="2668168" y="5341237"/>
-            <a:ext cx="2223662" cy="9525"/>
+            <a:off x="2691434" y="5449237"/>
+            <a:ext cx="2177131" cy="9525"/>
           </a:xfrm>
           <a:prstGeom prst="rect">
             <a:avLst/>
@@ -16079,8 +16289,8 @@
         </p:nvSpPr>
         <p:spPr>
           <a:xfrm>
-            <a:off x="4891831" y="5341237"/>
-            <a:ext cx="2223662" cy="9525"/>
+            <a:off x="4868565" y="5449237"/>
+            <a:ext cx="2177131" cy="9525"/>
           </a:xfrm>
           <a:prstGeom prst="rect">
             <a:avLst/>
@@ -16123,8 +16333,8 @@
         </p:nvSpPr>
         <p:spPr>
           <a:xfrm>
-            <a:off x="444506" y="7061650"/>
-            <a:ext cx="2223662" cy="9525"/>
+            <a:off x="514302" y="7133650"/>
+            <a:ext cx="2177131" cy="9525"/>
           </a:xfrm>
           <a:prstGeom prst="rect">
             <a:avLst/>
@@ -16167,8 +16377,8 @@
         </p:nvSpPr>
         <p:spPr>
           <a:xfrm>
-            <a:off x="2668168" y="7061650"/>
-            <a:ext cx="2223662" cy="9525"/>
+            <a:off x="2691434" y="7133650"/>
+            <a:ext cx="2177131" cy="9525"/>
           </a:xfrm>
           <a:prstGeom prst="rect">
             <a:avLst/>
@@ -16211,8 +16421,8 @@
         </p:nvSpPr>
         <p:spPr>
           <a:xfrm>
-            <a:off x="4891831" y="7061650"/>
-            <a:ext cx="2223662" cy="9525"/>
+            <a:off x="4868565" y="7133650"/>
+            <a:ext cx="2177131" cy="9525"/>
           </a:xfrm>
           <a:prstGeom prst="rect">
             <a:avLst/>
@@ -16255,8 +16465,8 @@
         </p:nvSpPr>
         <p:spPr>
           <a:xfrm>
-            <a:off x="444506" y="8782062"/>
-            <a:ext cx="2223662" cy="9525"/>
+            <a:off x="514302" y="8818062"/>
+            <a:ext cx="2177131" cy="9525"/>
           </a:xfrm>
           <a:prstGeom prst="rect">
             <a:avLst/>
@@ -16299,8 +16509,8 @@
         </p:nvSpPr>
         <p:spPr>
           <a:xfrm>
-            <a:off x="2668168" y="8782062"/>
-            <a:ext cx="2223662" cy="9525"/>
+            <a:off x="2691434" y="8818062"/>
+            <a:ext cx="2177131" cy="9525"/>
           </a:xfrm>
           <a:prstGeom prst="rect">
             <a:avLst/>
@@ -16343,8 +16553,8 @@
         </p:nvSpPr>
         <p:spPr>
           <a:xfrm>
-            <a:off x="4891831" y="8782062"/>
-            <a:ext cx="2223662" cy="9525"/>
+            <a:off x="4868565" y="8818062"/>
+            <a:ext cx="2177131" cy="9525"/>
           </a:xfrm>
           <a:prstGeom prst="rect">
             <a:avLst/>
@@ -16387,8 +16597,8 @@
         </p:nvSpPr>
         <p:spPr>
           <a:xfrm>
-            <a:off x="444506" y="10502475"/>
-            <a:ext cx="2223662" cy="9525"/>
+            <a:off x="514302" y="10502475"/>
+            <a:ext cx="2177131" cy="9525"/>
           </a:xfrm>
           <a:prstGeom prst="rect">
             <a:avLst/>
@@ -16431,8 +16641,8 @@
         </p:nvSpPr>
         <p:spPr>
           <a:xfrm>
-            <a:off x="2668168" y="10502475"/>
-            <a:ext cx="2223662" cy="9525"/>
+            <a:off x="2691434" y="10502475"/>
+            <a:ext cx="2177131" cy="9525"/>
           </a:xfrm>
           <a:prstGeom prst="rect">
             <a:avLst/>
@@ -16475,8 +16685,8 @@
         </p:nvSpPr>
         <p:spPr>
           <a:xfrm>
-            <a:off x="4891831" y="10502475"/>
-            <a:ext cx="2223662" cy="9525"/>
+            <a:off x="4868565" y="10502475"/>
+            <a:ext cx="2177131" cy="9525"/>
           </a:xfrm>
           <a:prstGeom prst="rect">
             <a:avLst/>
@@ -16519,8 +16729,8 @@
         </p:nvSpPr>
         <p:spPr>
           <a:xfrm>
-            <a:off x="439743" y="184762"/>
-            <a:ext cx="9525" cy="1720412"/>
+            <a:off x="509539" y="400762"/>
+            <a:ext cx="9525" cy="1684412"/>
           </a:xfrm>
           <a:prstGeom prst="rect">
             <a:avLst/>
@@ -16563,8 +16773,8 @@
         </p:nvSpPr>
         <p:spPr>
           <a:xfrm>
-            <a:off x="439743" y="1905175"/>
-            <a:ext cx="9525" cy="1720412"/>
+            <a:off x="509539" y="2085175"/>
+            <a:ext cx="9525" cy="1684412"/>
           </a:xfrm>
           <a:prstGeom prst="rect">
             <a:avLst/>
@@ -16607,8 +16817,8 @@
         </p:nvSpPr>
         <p:spPr>
           <a:xfrm>
-            <a:off x="439743" y="3625587"/>
-            <a:ext cx="9525" cy="1720412"/>
+            <a:off x="509539" y="3769587"/>
+            <a:ext cx="9525" cy="1684412"/>
           </a:xfrm>
           <a:prstGeom prst="rect">
             <a:avLst/>
@@ -16651,8 +16861,8 @@
         </p:nvSpPr>
         <p:spPr>
           <a:xfrm>
-            <a:off x="439743" y="5346000"/>
-            <a:ext cx="9525" cy="1720412"/>
+            <a:off x="509539" y="5454000"/>
+            <a:ext cx="9525" cy="1684412"/>
           </a:xfrm>
           <a:prstGeom prst="rect">
             <a:avLst/>
@@ -16695,8 +16905,8 @@
         </p:nvSpPr>
         <p:spPr>
           <a:xfrm>
-            <a:off x="439743" y="7066412"/>
-            <a:ext cx="9525" cy="1720412"/>
+            <a:off x="509539" y="7138412"/>
+            <a:ext cx="9525" cy="1684412"/>
           </a:xfrm>
           <a:prstGeom prst="rect">
             <a:avLst/>
@@ -16739,8 +16949,8 @@
         </p:nvSpPr>
         <p:spPr>
           <a:xfrm>
-            <a:off x="439743" y="8786825"/>
-            <a:ext cx="9525" cy="1720412"/>
+            <a:off x="509539" y="8822825"/>
+            <a:ext cx="9525" cy="1684412"/>
           </a:xfrm>
           <a:prstGeom prst="rect">
             <a:avLst/>
@@ -16783,8 +16993,8 @@
         </p:nvSpPr>
         <p:spPr>
           <a:xfrm>
-            <a:off x="2663406" y="184762"/>
-            <a:ext cx="9525" cy="1720412"/>
+            <a:off x="2686671" y="400762"/>
+            <a:ext cx="9525" cy="1684412"/>
           </a:xfrm>
           <a:prstGeom prst="rect">
             <a:avLst/>
@@ -16827,8 +17037,8 @@
         </p:nvSpPr>
         <p:spPr>
           <a:xfrm>
-            <a:off x="2663406" y="1905175"/>
-            <a:ext cx="9525" cy="1720412"/>
+            <a:off x="2686671" y="2085175"/>
+            <a:ext cx="9525" cy="1684412"/>
           </a:xfrm>
           <a:prstGeom prst="rect">
             <a:avLst/>
@@ -16871,8 +17081,8 @@
         </p:nvSpPr>
         <p:spPr>
           <a:xfrm>
-            <a:off x="2663406" y="3625587"/>
-            <a:ext cx="9525" cy="1720412"/>
+            <a:off x="2686671" y="3769587"/>
+            <a:ext cx="9525" cy="1684412"/>
           </a:xfrm>
           <a:prstGeom prst="rect">
             <a:avLst/>
@@ -16915,8 +17125,8 @@
         </p:nvSpPr>
         <p:spPr>
           <a:xfrm>
-            <a:off x="2663406" y="5346000"/>
-            <a:ext cx="9525" cy="1720412"/>
+            <a:off x="2686671" y="5454000"/>
+            <a:ext cx="9525" cy="1684412"/>
           </a:xfrm>
           <a:prstGeom prst="rect">
             <a:avLst/>
@@ -16959,8 +17169,8 @@
         </p:nvSpPr>
         <p:spPr>
           <a:xfrm>
-            <a:off x="2663406" y="7066412"/>
-            <a:ext cx="9525" cy="1720412"/>
+            <a:off x="2686671" y="7138412"/>
+            <a:ext cx="9525" cy="1684412"/>
           </a:xfrm>
           <a:prstGeom prst="rect">
             <a:avLst/>
@@ -17003,8 +17213,8 @@
         </p:nvSpPr>
         <p:spPr>
           <a:xfrm>
-            <a:off x="2663406" y="8786825"/>
-            <a:ext cx="9525" cy="1720412"/>
+            <a:off x="2686671" y="8822825"/>
+            <a:ext cx="9525" cy="1684412"/>
           </a:xfrm>
           <a:prstGeom prst="rect">
             <a:avLst/>
@@ -17047,8 +17257,8 @@
         </p:nvSpPr>
         <p:spPr>
           <a:xfrm>
-            <a:off x="4887068" y="184762"/>
-            <a:ext cx="9525" cy="1720412"/>
+            <a:off x="4863803" y="400762"/>
+            <a:ext cx="9525" cy="1684412"/>
           </a:xfrm>
           <a:prstGeom prst="rect">
             <a:avLst/>
@@ -17091,8 +17301,8 @@
         </p:nvSpPr>
         <p:spPr>
           <a:xfrm>
-            <a:off x="4887068" y="1905175"/>
-            <a:ext cx="9525" cy="1720412"/>
+            <a:off x="4863803" y="2085175"/>
+            <a:ext cx="9525" cy="1684412"/>
           </a:xfrm>
           <a:prstGeom prst="rect">
             <a:avLst/>
@@ -17135,8 +17345,8 @@
         </p:nvSpPr>
         <p:spPr>
           <a:xfrm>
-            <a:off x="4887068" y="3625587"/>
-            <a:ext cx="9525" cy="1720412"/>
+            <a:off x="4863803" y="3769587"/>
+            <a:ext cx="9525" cy="1684412"/>
           </a:xfrm>
           <a:prstGeom prst="rect">
             <a:avLst/>
@@ -17179,8 +17389,8 @@
         </p:nvSpPr>
         <p:spPr>
           <a:xfrm>
-            <a:off x="4887068" y="5346000"/>
-            <a:ext cx="9525" cy="1720412"/>
+            <a:off x="4863803" y="5454000"/>
+            <a:ext cx="9525" cy="1684412"/>
           </a:xfrm>
           <a:prstGeom prst="rect">
             <a:avLst/>
@@ -17223,8 +17433,8 @@
         </p:nvSpPr>
         <p:spPr>
           <a:xfrm>
-            <a:off x="4887068" y="7066412"/>
-            <a:ext cx="9525" cy="1720412"/>
+            <a:off x="4863803" y="7138412"/>
+            <a:ext cx="9525" cy="1684412"/>
           </a:xfrm>
           <a:prstGeom prst="rect">
             <a:avLst/>
@@ -17267,8 +17477,8 @@
         </p:nvSpPr>
         <p:spPr>
           <a:xfrm>
-            <a:off x="4887068" y="8786825"/>
-            <a:ext cx="9525" cy="1720412"/>
+            <a:off x="4863803" y="8822825"/>
+            <a:ext cx="9525" cy="1684412"/>
           </a:xfrm>
           <a:prstGeom prst="rect">
             <a:avLst/>
@@ -17311,8 +17521,8 @@
         </p:nvSpPr>
         <p:spPr>
           <a:xfrm>
-            <a:off x="7110731" y="184762"/>
-            <a:ext cx="9525" cy="1720412"/>
+            <a:off x="7040935" y="400762"/>
+            <a:ext cx="9525" cy="1684412"/>
           </a:xfrm>
           <a:prstGeom prst="rect">
             <a:avLst/>
@@ -17355,8 +17565,8 @@
         </p:nvSpPr>
         <p:spPr>
           <a:xfrm>
-            <a:off x="7110731" y="1905175"/>
-            <a:ext cx="9525" cy="1720412"/>
+            <a:off x="7040935" y="2085175"/>
+            <a:ext cx="9525" cy="1684412"/>
           </a:xfrm>
           <a:prstGeom prst="rect">
             <a:avLst/>
@@ -17399,8 +17609,8 @@
         </p:nvSpPr>
         <p:spPr>
           <a:xfrm>
-            <a:off x="7110731" y="3625587"/>
-            <a:ext cx="9525" cy="1720412"/>
+            <a:off x="7040935" y="3769587"/>
+            <a:ext cx="9525" cy="1684412"/>
           </a:xfrm>
           <a:prstGeom prst="rect">
             <a:avLst/>
@@ -17443,8 +17653,8 @@
         </p:nvSpPr>
         <p:spPr>
           <a:xfrm>
-            <a:off x="7110731" y="5346000"/>
-            <a:ext cx="9525" cy="1720412"/>
+            <a:off x="7040935" y="5454000"/>
+            <a:ext cx="9525" cy="1684412"/>
           </a:xfrm>
           <a:prstGeom prst="rect">
             <a:avLst/>
@@ -17487,8 +17697,8 @@
         </p:nvSpPr>
         <p:spPr>
           <a:xfrm>
-            <a:off x="7110731" y="7066412"/>
-            <a:ext cx="9525" cy="1720412"/>
+            <a:off x="7040935" y="7138412"/>
+            <a:ext cx="9525" cy="1684412"/>
           </a:xfrm>
           <a:prstGeom prst="rect">
             <a:avLst/>
@@ -17531,8 +17741,8 @@
         </p:nvSpPr>
         <p:spPr>
           <a:xfrm>
-            <a:off x="7110731" y="8786825"/>
-            <a:ext cx="9525" cy="1720412"/>
+            <a:off x="7040935" y="8822825"/>
+            <a:ext cx="9525" cy="1684412"/>
           </a:xfrm>
           <a:prstGeom prst="rect">
             <a:avLst/>
@@ -17564,6 +17774,41 @@
           <a:lstStyle/>
           <a:p>
             <a:pPr algn="ctr"/>
+          </a:p>
+        </p:txBody>
+      </p:sp>
+      <p:sp>
+        <p:nvSpPr>
+          <p:cNvPr id="65" name="TextBox 64"/>
+          <p:cNvSpPr txBox="1"/>
+          <p:nvPr/>
+        </p:nvSpPr>
+        <p:spPr>
+          <a:xfrm>
+            <a:off x="184762" y="184762"/>
+            <a:ext cx="7190475" cy="198000"/>
+          </a:xfrm>
+          <a:prstGeom prst="rect">
+            <a:avLst/>
+          </a:prstGeom>
+          <a:noFill/>
+        </p:spPr>
+        <p:txBody>
+          <a:bodyPr wrap="none" lIns="0" rIns="0" tIns="0" bIns="0">
+            <a:spAutoFit/>
+          </a:bodyPr>
+          <a:lstStyle/>
+          <a:p>
+            <a:pPr algn="l"/>
+            <a:r>
+              <a:rPr sz="900" b="0">
+                <a:solidFill>
+                  <a:srgbClr val="555555"/>
+                </a:solidFill>
+                <a:latin typeface="Arial"/>
+              </a:rPr>
+              <a:t>Карты букв · ЛИЦО</a:t>
+            </a:r>
           </a:p>
         </p:txBody>
       </p:sp>
@@ -17593,8 +17838,8 @@
         </p:nvSpPr>
         <p:spPr>
           <a:xfrm>
-            <a:off x="4891831" y="184762"/>
-            <a:ext cx="2223662" cy="1720412"/>
+            <a:off x="4868565" y="400762"/>
+            <a:ext cx="2177131" cy="1684412"/>
           </a:xfrm>
           <a:prstGeom prst="rect">
             <a:avLst/>
@@ -17635,8 +17880,8 @@
         </p:nvSpPr>
         <p:spPr>
           <a:xfrm>
-            <a:off x="2668168" y="184762"/>
-            <a:ext cx="2223662" cy="1720412"/>
+            <a:off x="2691434" y="400762"/>
+            <a:ext cx="2177131" cy="1684412"/>
           </a:xfrm>
           <a:prstGeom prst="rect">
             <a:avLst/>
@@ -17677,8 +17922,8 @@
         </p:nvSpPr>
         <p:spPr>
           <a:xfrm>
-            <a:off x="444506" y="184762"/>
-            <a:ext cx="2223662" cy="1720412"/>
+            <a:off x="514302" y="400762"/>
+            <a:ext cx="2177131" cy="1684412"/>
           </a:xfrm>
           <a:prstGeom prst="rect">
             <a:avLst/>
@@ -17719,8 +17964,8 @@
         </p:nvSpPr>
         <p:spPr>
           <a:xfrm>
-            <a:off x="4891831" y="1905175"/>
-            <a:ext cx="2223662" cy="1720412"/>
+            <a:off x="4868565" y="2085175"/>
+            <a:ext cx="2177131" cy="1684412"/>
           </a:xfrm>
           <a:prstGeom prst="rect">
             <a:avLst/>
@@ -17761,8 +18006,8 @@
         </p:nvSpPr>
         <p:spPr>
           <a:xfrm>
-            <a:off x="2668168" y="1905175"/>
-            <a:ext cx="2223662" cy="1720412"/>
+            <a:off x="2691434" y="2085175"/>
+            <a:ext cx="2177131" cy="1684412"/>
           </a:xfrm>
           <a:prstGeom prst="rect">
             <a:avLst/>
@@ -17803,8 +18048,8 @@
         </p:nvSpPr>
         <p:spPr>
           <a:xfrm>
-            <a:off x="444506" y="1905175"/>
-            <a:ext cx="2223662" cy="1720412"/>
+            <a:off x="514302" y="2085175"/>
+            <a:ext cx="2177131" cy="1684412"/>
           </a:xfrm>
           <a:prstGeom prst="rect">
             <a:avLst/>
@@ -17845,8 +18090,8 @@
         </p:nvSpPr>
         <p:spPr>
           <a:xfrm>
-            <a:off x="4891831" y="3625587"/>
-            <a:ext cx="2223662" cy="1720412"/>
+            <a:off x="4868565" y="3769587"/>
+            <a:ext cx="2177131" cy="1684412"/>
           </a:xfrm>
           <a:prstGeom prst="rect">
             <a:avLst/>
@@ -17887,8 +18132,8 @@
         </p:nvSpPr>
         <p:spPr>
           <a:xfrm>
-            <a:off x="2668168" y="3625587"/>
-            <a:ext cx="2223662" cy="1720412"/>
+            <a:off x="2691434" y="3769587"/>
+            <a:ext cx="2177131" cy="1684412"/>
           </a:xfrm>
           <a:prstGeom prst="rect">
             <a:avLst/>
@@ -17929,8 +18174,8 @@
         </p:nvSpPr>
         <p:spPr>
           <a:xfrm>
-            <a:off x="444506" y="3625587"/>
-            <a:ext cx="2223662" cy="1720412"/>
+            <a:off x="514302" y="3769587"/>
+            <a:ext cx="2177131" cy="1684412"/>
           </a:xfrm>
           <a:prstGeom prst="rect">
             <a:avLst/>
@@ -17971,8 +18216,8 @@
         </p:nvSpPr>
         <p:spPr>
           <a:xfrm>
-            <a:off x="4891831" y="5346000"/>
-            <a:ext cx="2223662" cy="1720412"/>
+            <a:off x="4868565" y="5454000"/>
+            <a:ext cx="2177131" cy="1684412"/>
           </a:xfrm>
           <a:prstGeom prst="rect">
             <a:avLst/>
@@ -18013,8 +18258,8 @@
         </p:nvSpPr>
         <p:spPr>
           <a:xfrm>
-            <a:off x="2668168" y="5346000"/>
-            <a:ext cx="2223662" cy="1720412"/>
+            <a:off x="2691434" y="5454000"/>
+            <a:ext cx="2177131" cy="1684412"/>
           </a:xfrm>
           <a:prstGeom prst="rect">
             <a:avLst/>
@@ -18055,8 +18300,8 @@
         </p:nvSpPr>
         <p:spPr>
           <a:xfrm>
-            <a:off x="444506" y="5346000"/>
-            <a:ext cx="2223662" cy="1720412"/>
+            <a:off x="514302" y="5454000"/>
+            <a:ext cx="2177131" cy="1684412"/>
           </a:xfrm>
           <a:prstGeom prst="rect">
             <a:avLst/>
@@ -18097,8 +18342,8 @@
         </p:nvSpPr>
         <p:spPr>
           <a:xfrm>
-            <a:off x="4891831" y="7066412"/>
-            <a:ext cx="2223662" cy="1720412"/>
+            <a:off x="4868565" y="7138412"/>
+            <a:ext cx="2177131" cy="1684412"/>
           </a:xfrm>
           <a:prstGeom prst="rect">
             <a:avLst/>
@@ -18139,8 +18384,8 @@
         </p:nvSpPr>
         <p:spPr>
           <a:xfrm>
-            <a:off x="2668168" y="7066412"/>
-            <a:ext cx="2223662" cy="1720412"/>
+            <a:off x="2691434" y="7138412"/>
+            <a:ext cx="2177131" cy="1684412"/>
           </a:xfrm>
           <a:prstGeom prst="rect">
             <a:avLst/>
@@ -18181,8 +18426,8 @@
         </p:nvSpPr>
         <p:spPr>
           <a:xfrm>
-            <a:off x="444506" y="7066412"/>
-            <a:ext cx="2223662" cy="1720412"/>
+            <a:off x="514302" y="7138412"/>
+            <a:ext cx="2177131" cy="1684412"/>
           </a:xfrm>
           <a:prstGeom prst="rect">
             <a:avLst/>
@@ -18223,8 +18468,8 @@
         </p:nvSpPr>
         <p:spPr>
           <a:xfrm>
-            <a:off x="4891831" y="8786825"/>
-            <a:ext cx="2223662" cy="1720412"/>
+            <a:off x="4868565" y="8822825"/>
+            <a:ext cx="2177131" cy="1684412"/>
           </a:xfrm>
           <a:prstGeom prst="rect">
             <a:avLst/>
@@ -18265,8 +18510,8 @@
         </p:nvSpPr>
         <p:spPr>
           <a:xfrm>
-            <a:off x="2668168" y="8786825"/>
-            <a:ext cx="2223662" cy="1720412"/>
+            <a:off x="2691434" y="8822825"/>
+            <a:ext cx="2177131" cy="1684412"/>
           </a:xfrm>
           <a:prstGeom prst="rect">
             <a:avLst/>
@@ -18307,8 +18552,8 @@
         </p:nvSpPr>
         <p:spPr>
           <a:xfrm>
-            <a:off x="444506" y="8786825"/>
-            <a:ext cx="2223662" cy="1720412"/>
+            <a:off x="514302" y="8822825"/>
+            <a:ext cx="2177131" cy="1684412"/>
           </a:xfrm>
           <a:prstGeom prst="rect">
             <a:avLst/>
@@ -18338,6 +18583,41 @@
           <a:lstStyle/>
           <a:p>
             <a:pPr algn="ctr"/>
+          </a:p>
+        </p:txBody>
+      </p:sp>
+      <p:sp>
+        <p:nvSpPr>
+          <p:cNvPr id="20" name="TextBox 19"/>
+          <p:cNvSpPr txBox="1"/>
+          <p:nvPr/>
+        </p:nvSpPr>
+        <p:spPr>
+          <a:xfrm>
+            <a:off x="184762" y="184762"/>
+            <a:ext cx="7190475" cy="198000"/>
+          </a:xfrm>
+          <a:prstGeom prst="rect">
+            <a:avLst/>
+          </a:prstGeom>
+          <a:noFill/>
+        </p:spPr>
+        <p:txBody>
+          <a:bodyPr wrap="none" lIns="0" rIns="0" tIns="0" bIns="0">
+            <a:spAutoFit/>
+          </a:bodyPr>
+          <a:lstStyle/>
+          <a:p>
+            <a:pPr algn="l"/>
+            <a:r>
+              <a:rPr sz="900" b="0">
+                <a:solidFill>
+                  <a:srgbClr val="555555"/>
+                </a:solidFill>
+                <a:latin typeface="Arial"/>
+              </a:rPr>
+              <a:t>Карты букв · ОБОРОТ</a:t>
+            </a:r>
           </a:p>
         </p:txBody>
       </p:sp>

</xml_diff>